<commit_message>
Wire month-start AR baseline file and UR tracking consolidation into the weekly deck
Co-Authored-By: Claude Fable 5.1 <noreply@anthropic.com>

Claude-Session: https://claude.ai/code/session_01GRGYp2p9fdXmxQMcLgyM1e
</commit_message>
<xml_diff>
--- a/weekly-ar-cash-deck/output/JESA_AR_Cash_Position_2026-10-21.pptx
+++ b/weekly-ar-cash-deck/output/JESA_AR_Cash_Position_2026-10-21.pptx
@@ -3591,7 +3591,7 @@
               <c:strCache>
                 <c:ptCount val="1"/>
                 <c:pt idx="0">
-                  <c:v>Δ vs 01-Aug</c:v>
+                  <c:v>Δ vs month start</c:v>
                 </c:pt>
               </c:strCache>
             </c:strRef>
@@ -3631,16 +3631,16 @@
                 <c:formatCode>General</c:formatCode>
                 <c:ptCount val="4"/>
                 <c:pt idx="0">
-                  <c:v>44.0</c:v>
+                  <c:v>0.0</c:v>
                 </c:pt>
                 <c:pt idx="1">
-                  <c:v>169.0</c:v>
+                  <c:v>-170.0</c:v>
                 </c:pt>
                 <c:pt idx="2">
-                  <c:v>-764.0</c:v>
+                  <c:v>6.0</c:v>
                 </c:pt>
                 <c:pt idx="3">
-                  <c:v>-551.0</c:v>
+                  <c:v>-164.0</c:v>
                 </c:pt>
               </c:numCache>
             </c:numRef>
@@ -4028,7 +4028,7 @@
                   <a:srgbClr val="1B2F4B"/>
                 </a:solidFill>
               </a:rPr>
-              <a:t>Total AR – Δ vs 01-Aug baseline by BU (MMAD)</a:t>
+              <a:t>Total AR – Δ vs month start (07-Oct) by BU (MMAD)</a:t>
             </a:r>
           </a:p>
         </c:rich>
@@ -4050,7 +4050,7 @@
               <c:strCache>
                 <c:ptCount val="1"/>
                 <c:pt idx="0">
-                  <c:v>Δ vs 01-Aug</c:v>
+                  <c:v>Δ vs 07-Oct</c:v>
                 </c:pt>
               </c:strCache>
             </c:strRef>
@@ -4105,31 +4105,31 @@
                 <c:formatCode>General</c:formatCode>
                 <c:ptCount val="9"/>
                 <c:pt idx="0">
-                  <c:v>-575.0</c:v>
+                  <c:v>-28.0</c:v>
                 </c:pt>
                 <c:pt idx="1">
-                  <c:v>46.0</c:v>
+                  <c:v>8.0</c:v>
                 </c:pt>
                 <c:pt idx="2">
-                  <c:v>115.0</c:v>
+                  <c:v>-92.0</c:v>
                 </c:pt>
                 <c:pt idx="3">
-                  <c:v>-42.0</c:v>
+                  <c:v>-44.0</c:v>
                 </c:pt>
                 <c:pt idx="4">
-                  <c:v>-86.0</c:v>
+                  <c:v>-2.0</c:v>
                 </c:pt>
                 <c:pt idx="5">
-                  <c:v>12.0</c:v>
+                  <c:v>-6.0</c:v>
                 </c:pt>
                 <c:pt idx="6">
-                  <c:v>42.0</c:v>
+                  <c:v>-1.0</c:v>
                 </c:pt>
                 <c:pt idx="7">
-                  <c:v>-64.0</c:v>
+                  <c:v>0.0</c:v>
                 </c:pt>
                 <c:pt idx="8">
-                  <c:v>-1.0</c:v>
+                  <c:v>1.0</c:v>
                 </c:pt>
               </c:numCache>
             </c:numRef>
@@ -4577,7 +4577,95 @@
               <c:strCache>
                 <c:ptCount val="1"/>
                 <c:pt idx="0">
-                  <c:v>Unrecognized</c:v>
+                  <c:v>Previous update</c:v>
+                </c:pt>
+              </c:strCache>
+            </c:strRef>
+          </c:tx>
+          <c:spPr>
+            <a:solidFill>
+              <a:srgbClr val="C9DDEE"/>
+            </a:solidFill>
+            <a:ln>
+              <a:noFill/>
+            </a:ln>
+          </c:spPr>
+          <c:cat>
+            <c:strRef>
+              <c:f>Sheet1!$A$2:$A$9</c:f>
+              <c:strCache>
+                <c:ptCount val="8"/>
+                <c:pt idx="0">
+                  <c:v>SP2M</c:v>
+                </c:pt>
+                <c:pt idx="1">
+                  <c:v>Water &amp; Env.</c:v>
+                </c:pt>
+                <c:pt idx="2">
+                  <c:v>Fert. &amp; Chem.</c:v>
+                </c:pt>
+                <c:pt idx="3">
+                  <c:v>Energy Ops</c:v>
+                </c:pt>
+                <c:pt idx="4">
+                  <c:v>JESA Tech</c:v>
+                </c:pt>
+                <c:pt idx="5">
+                  <c:v>Global Mining</c:v>
+                </c:pt>
+                <c:pt idx="6">
+                  <c:v>AM</c:v>
+                </c:pt>
+                <c:pt idx="7">
+                  <c:v>B&amp;I</c:v>
+                </c:pt>
+              </c:strCache>
+            </c:strRef>
+          </c:cat>
+          <c:val>
+            <c:numRef>
+              <c:f>Sheet1!$B$2:$B$9</c:f>
+              <c:numCache>
+                <c:formatCode>General</c:formatCode>
+                <c:ptCount val="8"/>
+                <c:pt idx="0">
+                  <c:v>3467.0</c:v>
+                </c:pt>
+                <c:pt idx="1">
+                  <c:v>1736.0</c:v>
+                </c:pt>
+                <c:pt idx="2">
+                  <c:v>1539.0</c:v>
+                </c:pt>
+                <c:pt idx="3">
+                  <c:v>114.0</c:v>
+                </c:pt>
+                <c:pt idx="4">
+                  <c:v>438.0</c:v>
+                </c:pt>
+                <c:pt idx="5">
+                  <c:v>347.0</c:v>
+                </c:pt>
+                <c:pt idx="6">
+                  <c:v>59.0</c:v>
+                </c:pt>
+                <c:pt idx="7">
+                  <c:v>95.0</c:v>
+                </c:pt>
+              </c:numCache>
+            </c:numRef>
+          </c:val>
+        </c:ser>
+        <c:ser>
+          <c:idx val="1"/>
+          <c:order val="1"/>
+          <c:tx>
+            <c:strRef>
+              <c:f>Sheet1!$C$1</c:f>
+              <c:strCache>
+                <c:ptCount val="1"/>
+                <c:pt idx="0">
+                  <c:v>Current</c:v>
                 </c:pt>
               </c:strCache>
             </c:strRef>
@@ -4624,18 +4712,18 @@
           </c:cat>
           <c:val>
             <c:numRef>
-              <c:f>Sheet1!$B$2:$B$9</c:f>
+              <c:f>Sheet1!$C$2:$C$9</c:f>
               <c:numCache>
                 <c:formatCode>General</c:formatCode>
                 <c:ptCount val="8"/>
                 <c:pt idx="0">
-                  <c:v>3670.0</c:v>
+                  <c:v>3271.0</c:v>
                 </c:pt>
                 <c:pt idx="1">
-                  <c:v>1513.0</c:v>
+                  <c:v>1511.0</c:v>
                 </c:pt>
                 <c:pt idx="2">
-                  <c:v>1387.0</c:v>
+                  <c:v>1382.0</c:v>
                 </c:pt>
                 <c:pt idx="3">
                   <c:v>362.0</c:v>
@@ -4644,13 +4732,13 @@
                   <c:v>252.0</c:v>
                 </c:pt>
                 <c:pt idx="5">
-                  <c:v>228.0</c:v>
+                  <c:v>160.0</c:v>
                 </c:pt>
                 <c:pt idx="6">
-                  <c:v>127.0</c:v>
+                  <c:v>132.0</c:v>
                 </c:pt>
                 <c:pt idx="7">
-                  <c:v>53.0</c:v>
+                  <c:v>58.0</c:v>
                 </c:pt>
               </c:numCache>
             </c:numRef>
@@ -4663,7 +4751,7 @@
             <a:lstStyle/>
             <a:p>
               <a:pPr>
-                <a:defRPr sz="900">
+                <a:defRPr sz="800">
                   <a:solidFill>
                     <a:srgbClr val="1F2A37"/>
                   </a:solidFill>
@@ -4750,6 +4838,21 @@
         <c:crosses val="autoZero"/>
       </c:valAx>
     </c:plotArea>
+    <c:legend>
+      <c:legendPos val="b"/>
+      <c:overlay val="0"/>
+      <c:txPr>
+        <a:bodyPr/>
+        <a:lstStyle/>
+        <a:p>
+          <a:pPr>
+            <a:defRPr sz="850">
+              <a:latin typeface="Arial"/>
+            </a:defRPr>
+          </a:pPr>
+        </a:p>
+      </c:txPr>
+    </c:legend>
     <c:dispBlanksAs val="gap"/>
   </c:chart>
   <c:txPr>
@@ -4863,16 +4966,16 @@
                 <c:formatCode>General</c:formatCode>
                 <c:ptCount val="5"/>
                 <c:pt idx="0">
-                  <c:v>245.0</c:v>
+                  <c:v>260.0</c:v>
                 </c:pt>
                 <c:pt idx="1">
-                  <c:v>25.0</c:v>
+                  <c:v>24.0</c:v>
                 </c:pt>
                 <c:pt idx="2">
-                  <c:v>1384.0</c:v>
+                  <c:v>1524.0</c:v>
                 </c:pt>
                 <c:pt idx="3">
-                  <c:v>386.0</c:v>
+                  <c:v>498.0</c:v>
                 </c:pt>
                 <c:pt idx="4">
                   <c:v>0.0</c:v>
@@ -4961,16 +5064,16 @@
                 <c:formatCode>General</c:formatCode>
                 <c:ptCount val="5"/>
                 <c:pt idx="0">
-                  <c:v>1042.0</c:v>
+                  <c:v>961.0</c:v>
                 </c:pt>
                 <c:pt idx="1">
-                  <c:v>339.0</c:v>
+                  <c:v>338.0</c:v>
                 </c:pt>
                 <c:pt idx="2">
-                  <c:v>1470.0</c:v>
+                  <c:v>2237.0</c:v>
                 </c:pt>
                 <c:pt idx="3">
-                  <c:v>1317.0</c:v>
+                  <c:v>1254.0</c:v>
                 </c:pt>
                 <c:pt idx="4">
                   <c:v>5.0</c:v>
@@ -5030,7 +5133,7 @@
           <a:lstStyle/>
           <a:p>
             <a:pPr>
-              <a:defRPr sz="800">
+              <a:defRPr sz="750">
                 <a:solidFill>
                   <a:srgbClr val="1F2A37"/>
                 </a:solidFill>
@@ -8861,7 +8964,7 @@
                 </a:solidFill>
                 <a:latin typeface="Arial"/>
               </a:rPr>
-              <a:t>Deck as of 21 Oct 2026   ·   AR snapshot 14 Oct 2026 (vs 07 Oct 2026 and 01 Aug 2026 baseline)   ·   Cash to 19/10   ·   Figures in MMAD</a:t>
+              <a:t>Deck as of 21 Oct 2026   ·   AR snapshot 14 Oct 2026 (vs 07 Oct 2026 and 07 Oct 2026 baseline)   ·   Cash to 19/10   ·   Figures in MMAD</a:t>
             </a:r>
           </a:p>
         </p:txBody>
@@ -8977,7 +9080,7 @@
                 </a:solidFill>
                 <a:latin typeface="Arial"/>
               </a:rPr>
-              <a:t>20,281</a:t>
+              <a:t>19,817</a:t>
             </a:r>
           </a:p>
         </p:txBody>
@@ -9128,7 +9231,7 @@
                 </a:solidFill>
                 <a:latin typeface="Arial"/>
               </a:rPr>
-              <a:t>7,592</a:t>
+              <a:t>7,128</a:t>
             </a:r>
           </a:p>
         </p:txBody>
@@ -31981,7 +32084,7 @@
         </p:nvGraphicFramePr>
         <p:xfrm>
           <a:off x="365760" y="1188720"/>
-          <a:ext cx="11430000" cy="3328416"/>
+          <a:ext cx="11430000" cy="3730752"/>
         </p:xfrm>
         <a:graphic>
           <a:graphicData uri="http://schemas.openxmlformats.org/drawingml/2006/table">
@@ -31995,7 +32098,7 @@
                 <a:gridCol w="2194560"/>
                 <a:gridCol w="2468880"/>
               </a:tblGrid>
-              <a:tr h="310896">
+              <a:tr h="292608">
                 <a:tc>
                   <a:txBody>
                     <a:bodyPr wrap="square"/>
@@ -32097,17 +32200,17 @@
                   </a:tcPr>
                 </a:tc>
               </a:tr>
-              <a:tr h="502920">
+              <a:tr h="429768">
                 <a:tc>
                   <a:txBody>
                     <a:bodyPr wrap="square"/>
                     <a:lstStyle/>
                     <a:p>
                       <a:pPr algn="l">
-                        <a:defRPr sz="900"/>
-                      </a:pPr>
-                      <a:r>
-                        <a:rPr sz="900" b="0">
+                        <a:defRPr sz="850"/>
+                      </a:pPr>
+                      <a:r>
+                        <a:rPr sz="850" b="0">
                           <a:solidFill>
                             <a:srgbClr val="1F2A37"/>
                           </a:solidFill>
@@ -32129,10 +32232,10 @@
                     <a:lstStyle/>
                     <a:p>
                       <a:pPr algn="l">
-                        <a:defRPr sz="900"/>
-                      </a:pPr>
-                      <a:r>
-                        <a:rPr sz="900" b="0">
+                        <a:defRPr sz="850"/>
+                      </a:pPr>
+                      <a:r>
+                        <a:rPr sz="850" b="0">
                           <a:solidFill>
                             <a:srgbClr val="1F2A37"/>
                           </a:solidFill>
@@ -32154,16 +32257,16 @@
                     <a:lstStyle/>
                     <a:p>
                       <a:pPr algn="l">
-                        <a:defRPr sz="900"/>
-                      </a:pPr>
-                      <a:r>
-                        <a:rPr sz="900" b="0">
-                          <a:solidFill>
-                            <a:srgbClr val="1F2A37"/>
-                          </a:solidFill>
-                          <a:latin typeface="Arial"/>
-                        </a:rPr>
-                        <a:t>Snapshot 14 Oct 2026; prev 07 Oct 2026; baseline 01 Aug 2026</a:t>
+                        <a:defRPr sz="850"/>
+                      </a:pPr>
+                      <a:r>
+                        <a:rPr sz="850" b="0">
+                          <a:solidFill>
+                            <a:srgbClr val="1F2A37"/>
+                          </a:solidFill>
+                          <a:latin typeface="Arial"/>
+                        </a:rPr>
+                        <a:t>Snapshot 14 Oct 2026; prev 07 Oct 2026; baseline 07 Oct 2026</a:t>
                       </a:r>
                     </a:p>
                   </a:txBody>
@@ -32179,10 +32282,10 @@
                     <a:lstStyle/>
                     <a:p>
                       <a:pPr algn="l">
-                        <a:defRPr sz="900"/>
-                      </a:pPr>
-                      <a:r>
-                        <a:rPr sz="900" b="0">
+                        <a:defRPr sz="850"/>
+                      </a:pPr>
+                      <a:r>
+                        <a:rPr sz="850" b="0">
                           <a:solidFill>
                             <a:srgbClr val="1F2A37"/>
                           </a:solidFill>
@@ -32199,17 +32302,17 @@
                   </a:tcPr>
                 </a:tc>
               </a:tr>
-              <a:tr h="502920">
+              <a:tr h="429768">
                 <a:tc>
                   <a:txBody>
                     <a:bodyPr wrap="square"/>
                     <a:lstStyle/>
                     <a:p>
                       <a:pPr algn="l">
-                        <a:defRPr sz="900"/>
-                      </a:pPr>
-                      <a:r>
-                        <a:rPr sz="900" b="0">
+                        <a:defRPr sz="850"/>
+                      </a:pPr>
+                      <a:r>
+                        <a:rPr sz="850" b="0">
                           <a:solidFill>
                             <a:srgbClr val="1F2A37"/>
                           </a:solidFill>
@@ -32231,10 +32334,10 @@
                     <a:lstStyle/>
                     <a:p>
                       <a:pPr algn="l">
-                        <a:defRPr sz="900"/>
-                      </a:pPr>
-                      <a:r>
-                        <a:rPr sz="900" b="0">
+                        <a:defRPr sz="850"/>
+                      </a:pPr>
+                      <a:r>
+                        <a:rPr sz="850" b="0">
                           <a:solidFill>
                             <a:srgbClr val="1F2A37"/>
                           </a:solidFill>
@@ -32256,10 +32359,10 @@
                     <a:lstStyle/>
                     <a:p>
                       <a:pPr algn="l">
-                        <a:defRPr sz="900"/>
-                      </a:pPr>
-                      <a:r>
-                        <a:rPr sz="900" b="0">
+                        <a:defRPr sz="850"/>
+                      </a:pPr>
+                      <a:r>
+                        <a:rPr sz="850" b="0">
                           <a:solidFill>
                             <a:srgbClr val="1F2A37"/>
                           </a:solidFill>
@@ -32281,10 +32384,10 @@
                     <a:lstStyle/>
                     <a:p>
                       <a:pPr algn="l">
-                        <a:defRPr sz="900"/>
-                      </a:pPr>
-                      <a:r>
-                        <a:rPr sz="900" b="0">
+                        <a:defRPr sz="850"/>
+                      </a:pPr>
+                      <a:r>
+                        <a:rPr sz="850" b="0">
                           <a:solidFill>
                             <a:srgbClr val="1F2A37"/>
                           </a:solidFill>
@@ -32301,17 +32404,221 @@
                   </a:tcPr>
                 </a:tc>
               </a:tr>
-              <a:tr h="502920">
+              <a:tr h="429768">
                 <a:tc>
                   <a:txBody>
                     <a:bodyPr wrap="square"/>
                     <a:lstStyle/>
                     <a:p>
                       <a:pPr algn="l">
-                        <a:defRPr sz="900"/>
-                      </a:pPr>
-                      <a:r>
-                        <a:rPr sz="900" b="0">
+                        <a:defRPr sz="850"/>
+                      </a:pPr>
+                      <a:r>
+                        <a:rPr sz="850" b="0">
+                          <a:solidFill>
+                            <a:srgbClr val="1F2A37"/>
+                          </a:solidFill>
+                          <a:latin typeface="Arial"/>
+                        </a:rPr>
+                        <a:t>Month-start baseline (AR by component, BU, status, aging)</a:t>
+                      </a:r>
+                    </a:p>
+                  </a:txBody>
+                  <a:tcPr marL="45720" marR="45720" marT="13716" marB="13716" anchor="ctr">
+                    <a:solidFill>
+                      <a:srgbClr val="FFFFFF"/>
+                    </a:solidFill>
+                  </a:tcPr>
+                </a:tc>
+                <a:tc>
+                  <a:txBody>
+                    <a:bodyPr wrap="square"/>
+                    <a:lstStyle/>
+                    <a:p>
+                      <a:pPr algn="l">
+                        <a:defRPr sz="850"/>
+                      </a:pPr>
+                      <a:r>
+                        <a:rPr sz="850" b="0">
+                          <a:solidFill>
+                            <a:srgbClr val="1F2A37"/>
+                          </a:solidFill>
+                          <a:latin typeface="Arial"/>
+                        </a:rPr>
+                        <a:t>Beginning-of-month AR line list (AR_Beg_of_the_month.xlsx) aggregated with the dashboard rules</a:t>
+                      </a:r>
+                    </a:p>
+                  </a:txBody>
+                  <a:tcPr marL="45720" marR="45720" marT="13716" marB="13716" anchor="ctr">
+                    <a:solidFill>
+                      <a:srgbClr val="FFFFFF"/>
+                    </a:solidFill>
+                  </a:tcPr>
+                </a:tc>
+                <a:tc>
+                  <a:txBody>
+                    <a:bodyPr wrap="square"/>
+                    <a:lstStyle/>
+                    <a:p>
+                      <a:pPr algn="l">
+                        <a:defRPr sz="850"/>
+                      </a:pPr>
+                      <a:r>
+                        <a:rPr sz="850" b="0">
+                          <a:solidFill>
+                            <a:srgbClr val="1F2A37"/>
+                          </a:solidFill>
+                          <a:latin typeface="Arial"/>
+                        </a:rPr>
+                        <a:t>AR position 07 Oct 2026</a:t>
+                      </a:r>
+                    </a:p>
+                  </a:txBody>
+                  <a:tcPr marL="45720" marR="45720" marT="13716" marB="13716" anchor="ctr">
+                    <a:solidFill>
+                      <a:srgbClr val="FFFFFF"/>
+                    </a:solidFill>
+                  </a:tcPr>
+                </a:tc>
+                <a:tc>
+                  <a:txBody>
+                    <a:bodyPr wrap="square"/>
+                    <a:lstStyle/>
+                    <a:p>
+                      <a:pPr algn="l">
+                        <a:defRPr sz="850"/>
+                      </a:pPr>
+                      <a:r>
+                        <a:rPr sz="850" b="0">
+                          <a:solidFill>
+                            <a:srgbClr val="1F2A37"/>
+                          </a:solidFill>
+                          <a:latin typeface="Arial"/>
+                        </a:rPr>
+                        <a:t>AR_KPI / AR_BU / AR_* month_start columns</a:t>
+                      </a:r>
+                    </a:p>
+                  </a:txBody>
+                  <a:tcPr marL="45720" marR="45720" marT="13716" marB="13716" anchor="ctr">
+                    <a:solidFill>
+                      <a:srgbClr val="FFFFFF"/>
+                    </a:solidFill>
+                  </a:tcPr>
+                </a:tc>
+              </a:tr>
+              <a:tr h="429768">
+                <a:tc>
+                  <a:txBody>
+                    <a:bodyPr wrap="square"/>
+                    <a:lstStyle/>
+                    <a:p>
+                      <a:pPr algn="l">
+                        <a:defRPr sz="850"/>
+                      </a:pPr>
+                      <a:r>
+                        <a:rPr sz="850" b="0">
+                          <a:solidFill>
+                            <a:srgbClr val="1F2A37"/>
+                          </a:solidFill>
+                          <a:latin typeface="Arial"/>
+                        </a:rPr>
+                        <a:t>Unrecognized revenue by BU and status, previous BU update, PO book</a:t>
+                      </a:r>
+                    </a:p>
+                  </a:txBody>
+                  <a:tcPr marL="45720" marR="45720" marT="13716" marB="13716" anchor="ctr">
+                    <a:solidFill>
+                      <a:srgbClr val="E9F0F6"/>
+                    </a:solidFill>
+                  </a:tcPr>
+                </a:tc>
+                <a:tc>
+                  <a:txBody>
+                    <a:bodyPr wrap="square"/>
+                    <a:lstStyle/>
+                    <a:p>
+                      <a:pPr algn="l">
+                        <a:defRPr sz="850"/>
+                      </a:pPr>
+                      <a:r>
+                        <a:rPr sz="850" b="0">
+                          <a:solidFill>
+                            <a:srgbClr val="1F2A37"/>
+                          </a:solidFill>
+                          <a:latin typeface="Arial"/>
+                        </a:rPr>
+                        <a:t>UR Tracking Consolidation – 'Summary UR', 'Sheet1', 'Summary PO by BU'</a:t>
+                      </a:r>
+                    </a:p>
+                  </a:txBody>
+                  <a:tcPr marL="45720" marR="45720" marT="13716" marB="13716" anchor="ctr">
+                    <a:solidFill>
+                      <a:srgbClr val="E9F0F6"/>
+                    </a:solidFill>
+                  </a:tcPr>
+                </a:tc>
+                <a:tc>
+                  <a:txBody>
+                    <a:bodyPr wrap="square"/>
+                    <a:lstStyle/>
+                    <a:p>
+                      <a:pPr algn="l">
+                        <a:defRPr sz="850"/>
+                      </a:pPr>
+                      <a:r>
+                        <a:rPr sz="850" b="0">
+                          <a:solidFill>
+                            <a:srgbClr val="1F2A37"/>
+                          </a:solidFill>
+                          <a:latin typeface="Arial"/>
+                        </a:rPr>
+                        <a:t>21 Oct 2026</a:t>
+                      </a:r>
+                    </a:p>
+                  </a:txBody>
+                  <a:tcPr marL="45720" marR="45720" marT="13716" marB="13716" anchor="ctr">
+                    <a:solidFill>
+                      <a:srgbClr val="E9F0F6"/>
+                    </a:solidFill>
+                  </a:tcPr>
+                </a:tc>
+                <a:tc>
+                  <a:txBody>
+                    <a:bodyPr wrap="square"/>
+                    <a:lstStyle/>
+                    <a:p>
+                      <a:pPr algn="l">
+                        <a:defRPr sz="850"/>
+                      </a:pPr>
+                      <a:r>
+                        <a:rPr sz="850" b="0">
+                          <a:solidFill>
+                            <a:srgbClr val="1F2A37"/>
+                          </a:solidFill>
+                          <a:latin typeface="Arial"/>
+                        </a:rPr>
+                        <a:t>UNRECOGNIZED, UR_ATTACHMENT_STATUS, UR_PO_SUMMARY</a:t>
+                      </a:r>
+                    </a:p>
+                  </a:txBody>
+                  <a:tcPr marL="45720" marR="45720" marT="13716" marB="13716" anchor="ctr">
+                    <a:solidFill>
+                      <a:srgbClr val="E9F0F6"/>
+                    </a:solidFill>
+                  </a:tcPr>
+                </a:tc>
+              </a:tr>
+              <a:tr h="429768">
+                <a:tc>
+                  <a:txBody>
+                    <a:bodyPr wrap="square"/>
+                    <a:lstStyle/>
+                    <a:p>
+                      <a:pPr algn="l">
+                        <a:defRPr sz="850"/>
+                      </a:pPr>
+                      <a:r>
+                        <a:rPr sz="850" b="0">
                           <a:solidFill>
                             <a:srgbClr val="1F2A37"/>
                           </a:solidFill>
@@ -32333,10 +32640,10 @@
                     <a:lstStyle/>
                     <a:p>
                       <a:pPr algn="l">
-                        <a:defRPr sz="900"/>
-                      </a:pPr>
-                      <a:r>
-                        <a:rPr sz="900" b="0">
+                        <a:defRPr sz="850"/>
+                      </a:pPr>
+                      <a:r>
+                        <a:rPr sz="850" b="0">
                           <a:solidFill>
                             <a:srgbClr val="1F2A37"/>
                           </a:solidFill>
@@ -32358,10 +32665,10 @@
                     <a:lstStyle/>
                     <a:p>
                       <a:pPr algn="l">
-                        <a:defRPr sz="900"/>
-                      </a:pPr>
-                      <a:r>
-                        <a:rPr sz="900" b="0">
+                        <a:defRPr sz="850"/>
+                      </a:pPr>
+                      <a:r>
+                        <a:rPr sz="850" b="0">
                           <a:solidFill>
                             <a:srgbClr val="1F2A37"/>
                           </a:solidFill>
@@ -32383,10 +32690,10 @@
                     <a:lstStyle/>
                     <a:p>
                       <a:pPr algn="l">
-                        <a:defRPr sz="900"/>
-                      </a:pPr>
-                      <a:r>
-                        <a:rPr sz="900" b="0">
+                        <a:defRPr sz="850"/>
+                      </a:pPr>
+                      <a:r>
+                        <a:rPr sz="850" b="0">
                           <a:solidFill>
                             <a:srgbClr val="1F2A37"/>
                           </a:solidFill>
@@ -32403,17 +32710,17 @@
                   </a:tcPr>
                 </a:tc>
               </a:tr>
-              <a:tr h="502920">
+              <a:tr h="429768">
                 <a:tc>
                   <a:txBody>
                     <a:bodyPr wrap="square"/>
                     <a:lstStyle/>
                     <a:p>
                       <a:pPr algn="l">
-                        <a:defRPr sz="900"/>
-                      </a:pPr>
-                      <a:r>
-                        <a:rPr sz="900" b="0">
+                        <a:defRPr sz="850"/>
+                      </a:pPr>
+                      <a:r>
+                        <a:rPr sz="850" b="0">
                           <a:solidFill>
                             <a:srgbClr val="1F2A37"/>
                           </a:solidFill>
@@ -32435,10 +32742,10 @@
                     <a:lstStyle/>
                     <a:p>
                       <a:pPr algn="l">
-                        <a:defRPr sz="900"/>
-                      </a:pPr>
-                      <a:r>
-                        <a:rPr sz="900" b="0">
+                        <a:defRPr sz="850"/>
+                      </a:pPr>
+                      <a:r>
+                        <a:rPr sz="850" b="0">
                           <a:solidFill>
                             <a:srgbClr val="1F2A37"/>
                           </a:solidFill>
@@ -32460,10 +32767,10 @@
                     <a:lstStyle/>
                     <a:p>
                       <a:pPr algn="l">
-                        <a:defRPr sz="900"/>
-                      </a:pPr>
-                      <a:r>
-                        <a:rPr sz="900" b="0">
+                        <a:defRPr sz="850"/>
+                      </a:pPr>
+                      <a:r>
+                        <a:rPr sz="850" b="0">
                           <a:solidFill>
                             <a:srgbClr val="1F2A37"/>
                           </a:solidFill>
@@ -32485,10 +32792,10 @@
                     <a:lstStyle/>
                     <a:p>
                       <a:pPr algn="l">
-                        <a:defRPr sz="900"/>
-                      </a:pPr>
-                      <a:r>
-                        <a:rPr sz="900" b="0">
+                        <a:defRPr sz="850"/>
+                      </a:pPr>
+                      <a:r>
+                        <a:rPr sz="850" b="0">
                           <a:solidFill>
                             <a:srgbClr val="1F2A37"/>
                           </a:solidFill>
@@ -32505,17 +32812,17 @@
                   </a:tcPr>
                 </a:tc>
               </a:tr>
-              <a:tr h="502920">
+              <a:tr h="429768">
                 <a:tc>
                   <a:txBody>
                     <a:bodyPr wrap="square"/>
                     <a:lstStyle/>
                     <a:p>
                       <a:pPr algn="l">
-                        <a:defRPr sz="900"/>
-                      </a:pPr>
-                      <a:r>
-                        <a:rPr sz="900" b="0">
+                        <a:defRPr sz="850"/>
+                      </a:pPr>
+                      <a:r>
+                        <a:rPr sz="850" b="0">
                           <a:solidFill>
                             <a:srgbClr val="1F2A37"/>
                           </a:solidFill>
@@ -32537,10 +32844,10 @@
                     <a:lstStyle/>
                     <a:p>
                       <a:pPr algn="l">
-                        <a:defRPr sz="900"/>
-                      </a:pPr>
-                      <a:r>
-                        <a:rPr sz="900" b="0">
+                        <a:defRPr sz="850"/>
+                      </a:pPr>
+                      <a:r>
+                        <a:rPr sz="850" b="0">
                           <a:solidFill>
                             <a:srgbClr val="1F2A37"/>
                           </a:solidFill>
@@ -32562,10 +32869,10 @@
                     <a:lstStyle/>
                     <a:p>
                       <a:pPr algn="l">
-                        <a:defRPr sz="900"/>
-                      </a:pPr>
-                      <a:r>
-                        <a:rPr sz="900" b="0">
+                        <a:defRPr sz="850"/>
+                      </a:pPr>
+                      <a:r>
+                        <a:rPr sz="850" b="0">
                           <a:solidFill>
                             <a:srgbClr val="1F2A37"/>
                           </a:solidFill>
@@ -32587,10 +32894,10 @@
                     <a:lstStyle/>
                     <a:p>
                       <a:pPr algn="l">
-                        <a:defRPr sz="900"/>
-                      </a:pPr>
-                      <a:r>
-                        <a:rPr sz="900" b="0">
+                        <a:defRPr sz="850"/>
+                      </a:pPr>
+                      <a:r>
+                        <a:rPr sz="850" b="0">
                           <a:solidFill>
                             <a:srgbClr val="1F2A37"/>
                           </a:solidFill>
@@ -32607,17 +32914,17 @@
                   </a:tcPr>
                 </a:tc>
               </a:tr>
-              <a:tr h="502920">
+              <a:tr h="429768">
                 <a:tc>
                   <a:txBody>
                     <a:bodyPr wrap="square"/>
                     <a:lstStyle/>
                     <a:p>
                       <a:pPr algn="l">
-                        <a:defRPr sz="900"/>
-                      </a:pPr>
-                      <a:r>
-                        <a:rPr sz="900" b="0">
+                        <a:defRPr sz="850"/>
+                      </a:pPr>
+                      <a:r>
+                        <a:rPr sz="850" b="0">
                           <a:solidFill>
                             <a:srgbClr val="1F2A37"/>
                           </a:solidFill>
@@ -32639,10 +32946,10 @@
                     <a:lstStyle/>
                     <a:p>
                       <a:pPr algn="l">
-                        <a:defRPr sz="900"/>
-                      </a:pPr>
-                      <a:r>
-                        <a:rPr sz="900" b="0">
+                        <a:defRPr sz="850"/>
+                      </a:pPr>
+                      <a:r>
+                        <a:rPr sz="850" b="0">
                           <a:solidFill>
                             <a:srgbClr val="1F2A37"/>
                           </a:solidFill>
@@ -32664,10 +32971,10 @@
                     <a:lstStyle/>
                     <a:p>
                       <a:pPr algn="l">
-                        <a:defRPr sz="900"/>
-                      </a:pPr>
-                      <a:r>
-                        <a:rPr sz="900" b="0">
+                        <a:defRPr sz="850"/>
+                      </a:pPr>
+                      <a:r>
+                        <a:rPr sz="850" b="0">
                           <a:solidFill>
                             <a:srgbClr val="1F2A37"/>
                           </a:solidFill>
@@ -32689,10 +32996,10 @@
                     <a:lstStyle/>
                     <a:p>
                       <a:pPr algn="l">
-                        <a:defRPr sz="900"/>
-                      </a:pPr>
-                      <a:r>
-                        <a:rPr sz="900" b="0">
+                        <a:defRPr sz="850"/>
+                      </a:pPr>
+                      <a:r>
+                        <a:rPr sz="850" b="0">
                           <a:solidFill>
                             <a:srgbClr val="1F2A37"/>
                           </a:solidFill>
@@ -32721,8 +33028,8 @@
         </p:nvSpPr>
         <p:spPr>
           <a:xfrm>
-            <a:off x="365760" y="4663440"/>
-            <a:ext cx="11430000" cy="1737360"/>
+            <a:off x="365760" y="5074920"/>
+            <a:ext cx="11430000" cy="1371600"/>
           </a:xfrm>
           <a:prstGeom prst="rect">
             <a:avLst/>
@@ -32756,7 +33063,7 @@
                 </a:solidFill>
                 <a:latin typeface="Arial"/>
               </a:rPr>
-              <a:t>1) drop the four refreshed source files  →  2) run extract_inputs.py (dates as parameters)  →  3) review / edit weekly_inputs.xlsx (key messages, monthly split)  →  4) run build_deck.py.</a:t>
+              <a:t>1) drop the refreshed source files (AR dashboard, cash flow workbook, LC situation, supplier invoices, UR consolidation; month-start AR file once a month)  →  2) run extract_inputs.py (dates as parameters)  →  3) review / edit weekly_inputs.xlsx (key messages, monthly split)  →  4) run build_deck.py.</a:t>
             </a:r>
           </a:p>
           <a:p>
@@ -32781,7 +33088,7 @@
                 </a:solidFill>
                 <a:latin typeface="Arial"/>
               </a:rPr>
-              <a:t>week-on-week uses the AR dashboard 'Snapshot' tab (07 Oct 2026); 'vs month start' uses the dashboard 'AR Baseline' tab, currently saved on 01 Aug 2026. Re-save the baseline on the first working day of each month so that the column reads as a true month-to-date comparison.</a:t>
+              <a:t>week-on-week uses the AR dashboard 'Snapshot' tab (07 Oct 2026); 'vs month start' uses the beginning-of-month AR file (07 Oct 2026 position), aggregated with the dashboard rules (unearned-on-LS and negative advance lines excluded).</a:t>
             </a:r>
           </a:p>
           <a:p>
@@ -33183,7 +33490,7 @@
                 </a:solidFill>
                 <a:latin typeface="Arial"/>
               </a:rPr>
-              <a:t>Total AR down 162 MMAD vs last week and down 551 MMAD vs the 01 Aug baseline</a:t>
+              <a:t>Total AR down 162 MMAD vs last week and down 164 MMAD vs the month-start (07 Oct) baseline</a:t>
             </a:r>
           </a:p>
         </p:txBody>
@@ -33222,7 +33529,7 @@
                 </a:solidFill>
                 <a:latin typeface="Arial"/>
               </a:rPr>
-              <a:t>Total AR stands at 12,689 MMAD (−162 WoW, −551 vs baseline). Adding 7,592 MMAD of unrecognized revenue, gross exposure is 20,281 MMAD. Unbilled is 9,514 MMAD (75% of AR, −168 WoW); unpaid is 2,627 MMAD (+6 WoW, −764 vs baseline).</a:t>
+              <a:t>Total AR stands at 12,689 MMAD (−162 WoW, −164 vs month start). Adding 7,128 MMAD of unrecognized revenue (−666 vs the previous BU update), gross exposure is 19,817 MMAD. Unbilled is 9,514 MMAD (75% of AR, −168 WoW); unpaid is 2,627 MMAD (+6 WoW, +6 vs baseline).</a:t>
             </a:r>
           </a:p>
         </p:txBody>
@@ -33525,7 +33832,7 @@
                 </a:solidFill>
                 <a:latin typeface="Arial"/>
               </a:rPr>
-              <a:t>Procurement cash position: net -171 MMAD Jul–Oct including October commitments</a:t>
+              <a:t>Procurement cash position: net −171 MMAD Jul–Oct including October commitments</a:t>
             </a:r>
           </a:p>
         </p:txBody>
@@ -34125,7 +34432,7 @@
                 </a:solidFill>
                 <a:latin typeface="Arial"/>
               </a:rPr>
-              <a:t>Unbilled is 75% of total AR; AR −162 MMAD week on week and −551 vs the 01-Aug baseline</a:t>
+              <a:t>Unbilled is 75% of total AR; AR −162 MMAD week on week and −164 vs the month-start baseline (07-Oct)</a:t>
             </a:r>
           </a:p>
         </p:txBody>
@@ -34357,7 +34664,7 @@
                 </a:solidFill>
                 <a:latin typeface="Arial"/>
               </a:rPr>
-              <a:t>20,281</a:t>
+              <a:t>19,817</a:t>
             </a:r>
           </a:p>
         </p:txBody>
@@ -34401,7 +34708,7 @@
                 </a:solidFill>
                 <a:latin typeface="Arial"/>
               </a:rPr>
-              <a:t>−122</a:t>
+              <a:t>−828</a:t>
             </a:r>
           </a:p>
         </p:txBody>
@@ -34563,7 +34870,7 @@
                 </a:solidFill>
                 <a:latin typeface="Arial"/>
               </a:rPr>
-              <a:t>7,592</a:t>
+              <a:t>7,128</a:t>
             </a:r>
           </a:p>
         </p:txBody>
@@ -34603,11 +34910,11 @@
             <a:r>
               <a:rPr sz="1000" b="1" i="0">
                 <a:solidFill>
-                  <a:srgbClr val="B5473A"/>
+                  <a:srgbClr val="2E7D4F"/>
                 </a:solidFill>
                 <a:latin typeface="Arial"/>
               </a:rPr>
-              <a:t>+40</a:t>
+              <a:t>−666</a:t>
             </a:r>
           </a:p>
         </p:txBody>
@@ -34848,7 +35155,7 @@
                 </a:solidFill>
                 <a:latin typeface="Arial"/>
               </a:rPr>
-              <a:t>vs 01-Aug  </a:t>
+              <a:t>vs month start  </a:t>
             </a:r>
             <a:r>
               <a:rPr sz="1000" b="1" i="0">
@@ -34857,7 +35164,7 @@
                 </a:solidFill>
                 <a:latin typeface="Arial"/>
               </a:rPr>
-              <a:t>−551</a:t>
+              <a:t>−164</a:t>
             </a:r>
           </a:p>
         </p:txBody>
@@ -35098,16 +35405,16 @@
                 </a:solidFill>
                 <a:latin typeface="Arial"/>
               </a:rPr>
-              <a:t>vs 01-Aug  </a:t>
+              <a:t>vs month start  </a:t>
             </a:r>
             <a:r>
               <a:rPr sz="1000" b="1" i="0">
                 <a:solidFill>
-                  <a:srgbClr val="B5473A"/>
+                  <a:srgbClr val="2E7D4F"/>
                 </a:solidFill>
                 <a:latin typeface="Arial"/>
               </a:rPr>
-              <a:t>+169</a:t>
+              <a:t>−170</a:t>
             </a:r>
           </a:p>
         </p:txBody>
@@ -35348,16 +35655,16 @@
                 </a:solidFill>
                 <a:latin typeface="Arial"/>
               </a:rPr>
-              <a:t>vs 01-Aug  </a:t>
+              <a:t>vs month start  </a:t>
             </a:r>
             <a:r>
               <a:rPr sz="1000" b="1" i="0">
                 <a:solidFill>
-                  <a:srgbClr val="2E7D4F"/>
+                  <a:srgbClr val="B5473A"/>
                 </a:solidFill>
                 <a:latin typeface="Arial"/>
               </a:rPr>
-              <a:t>−764</a:t>
+              <a:t>+6</a:t>
             </a:r>
           </a:p>
         </p:txBody>
@@ -35598,16 +35905,16 @@
                 </a:solidFill>
                 <a:latin typeface="Arial"/>
               </a:rPr>
-              <a:t>vs 01-Aug  </a:t>
+              <a:t>vs month start  </a:t>
             </a:r>
             <a:r>
               <a:rPr sz="1000" b="1" i="0">
                 <a:solidFill>
-                  <a:srgbClr val="B5473A"/>
+                  <a:srgbClr val="7A8794"/>
                 </a:solidFill>
                 <a:latin typeface="Arial"/>
               </a:rPr>
-              <a:t>+44</a:t>
+              <a:t>0</a:t>
             </a:r>
           </a:p>
         </p:txBody>
@@ -36530,7 +36837,7 @@
                 </a:solidFill>
                 <a:latin typeface="Arial"/>
               </a:rPr>
-              <a:t>This week 14-Oct vs last week 07-Oct and vs the 01-Aug baseline saved in the AR dashboard</a:t>
+              <a:t>This week 14-Oct vs last week 07-Oct and vs the month-start baseline (07-Oct AR position)</a:t>
             </a:r>
           </a:p>
         </p:txBody>
@@ -36674,8 +36981,8 @@
                           </a:solidFill>
                           <a:latin typeface="Arial"/>
                         </a:rPr>
-                        <a:t>Baseline
-01-Aug</a:t>
+                        <a:t>Month start
+07-Oct</a:t>
                       </a:r>
                     </a:p>
                   </a:txBody>
@@ -36803,7 +37110,7 @@
                           <a:latin typeface="Arial"/>
                         </a:rPr>
                         <a:t>Δ vs
-01-Aug</a:t>
+month start</a:t>
                       </a:r>
                     </a:p>
                   </a:txBody>
@@ -36829,7 +37136,7 @@
                           <a:latin typeface="Arial"/>
                         </a:rPr>
                         <a:t>Δ% vs
-01-Aug</a:t>
+month start</a:t>
                       </a:r>
                     </a:p>
                   </a:txBody>
@@ -36881,7 +37188,7 @@
                           </a:solidFill>
                           <a:latin typeface="Arial"/>
                         </a:rPr>
-                        <a:t>503</a:t>
+                        <a:t>547</a:t>
                       </a:r>
                     </a:p>
                   </a:txBody>
@@ -37006,7 +37313,7 @@
                           </a:solidFill>
                           <a:latin typeface="Arial"/>
                         </a:rPr>
-                        <a:t>+44</a:t>
+                        <a:t>0</a:t>
                       </a:r>
                     </a:p>
                   </a:txBody>
@@ -37031,7 +37338,7 @@
                           </a:solidFill>
                           <a:latin typeface="Arial"/>
                         </a:rPr>
-                        <a:t>+8.8%</a:t>
+                        <a:t>+0.0%</a:t>
                       </a:r>
                     </a:p>
                   </a:txBody>
@@ -37083,7 +37390,7 @@
                           </a:solidFill>
                           <a:latin typeface="Arial"/>
                         </a:rPr>
-                        <a:t>9,345</a:t>
+                        <a:t>9,684</a:t>
                       </a:r>
                     </a:p>
                   </a:txBody>
@@ -37208,7 +37515,7 @@
                           </a:solidFill>
                           <a:latin typeface="Arial"/>
                         </a:rPr>
-                        <a:t>+169</a:t>
+                        <a:t>−170</a:t>
                       </a:r>
                     </a:p>
                   </a:txBody>
@@ -37233,7 +37540,7 @@
                           </a:solidFill>
                           <a:latin typeface="Arial"/>
                         </a:rPr>
-                        <a:t>+1.8%</a:t>
+                        <a:t>−1.8%</a:t>
                       </a:r>
                     </a:p>
                   </a:txBody>
@@ -37285,7 +37592,7 @@
                           </a:solidFill>
                           <a:latin typeface="Arial"/>
                         </a:rPr>
-                        <a:t>3,391</a:t>
+                        <a:t>2,622</a:t>
                       </a:r>
                     </a:p>
                   </a:txBody>
@@ -37410,7 +37717,7 @@
                           </a:solidFill>
                           <a:latin typeface="Arial"/>
                         </a:rPr>
-                        <a:t>−764</a:t>
+                        <a:t>+6</a:t>
                       </a:r>
                     </a:p>
                   </a:txBody>
@@ -37435,7 +37742,7 @@
                           </a:solidFill>
                           <a:latin typeface="Arial"/>
                         </a:rPr>
-                        <a:t>−22.5%</a:t>
+                        <a:t>+0.2%</a:t>
                       </a:r>
                     </a:p>
                   </a:txBody>
@@ -37487,7 +37794,7 @@
                           </a:solidFill>
                           <a:latin typeface="Arial"/>
                         </a:rPr>
-                        <a:t>13,240</a:t>
+                        <a:t>12,853</a:t>
                       </a:r>
                     </a:p>
                   </a:txBody>
@@ -37612,7 +37919,7 @@
                           </a:solidFill>
                           <a:latin typeface="Arial"/>
                         </a:rPr>
-                        <a:t>−551</a:t>
+                        <a:t>−164</a:t>
                       </a:r>
                     </a:p>
                   </a:txBody>
@@ -37637,7 +37944,7 @@
                           </a:solidFill>
                           <a:latin typeface="Arial"/>
                         </a:rPr>
-                        <a:t>−4.2%</a:t>
+                        <a:t>−1.3%</a:t>
                       </a:r>
                     </a:p>
                   </a:txBody>
@@ -37714,7 +38021,7 @@
                           </a:solidFill>
                           <a:latin typeface="Arial"/>
                         </a:rPr>
-                        <a:t>7,552</a:t>
+                        <a:t>7,794</a:t>
                       </a:r>
                     </a:p>
                   </a:txBody>
@@ -37739,7 +38046,7 @@
                           </a:solidFill>
                           <a:latin typeface="Arial"/>
                         </a:rPr>
-                        <a:t>7,592</a:t>
+                        <a:t>7,128</a:t>
                       </a:r>
                     </a:p>
                   </a:txBody>
@@ -37764,7 +38071,7 @@
                           </a:solidFill>
                           <a:latin typeface="Arial"/>
                         </a:rPr>
-                        <a:t>+40</a:t>
+                        <a:t>−666</a:t>
                       </a:r>
                     </a:p>
                   </a:txBody>
@@ -37789,7 +38096,7 @@
                           </a:solidFill>
                           <a:latin typeface="Arial"/>
                         </a:rPr>
-                        <a:t>+0.5%</a:t>
+                        <a:t>−8.5%</a:t>
                       </a:r>
                     </a:p>
                   </a:txBody>
@@ -37916,7 +38223,7 @@
                           </a:solidFill>
                           <a:latin typeface="Arial"/>
                         </a:rPr>
-                        <a:t>20,403</a:t>
+                        <a:t>20,645</a:t>
                       </a:r>
                     </a:p>
                   </a:txBody>
@@ -37941,7 +38248,7 @@
                           </a:solidFill>
                           <a:latin typeface="Arial"/>
                         </a:rPr>
-                        <a:t>20,281</a:t>
+                        <a:t>19,817</a:t>
                       </a:r>
                     </a:p>
                   </a:txBody>
@@ -37966,7 +38273,7 @@
                           </a:solidFill>
                           <a:latin typeface="Arial"/>
                         </a:rPr>
-                        <a:t>−122</a:t>
+                        <a:t>−828</a:t>
                       </a:r>
                     </a:p>
                   </a:txBody>
@@ -37991,7 +38298,7 @@
                           </a:solidFill>
                           <a:latin typeface="Arial"/>
                         </a:rPr>
-                        <a:t>−0.6%</a:t>
+                        <a:t>−4.0%</a:t>
                       </a:r>
                     </a:p>
                   </a:txBody>
@@ -38227,7 +38534,7 @@
                 </a:solidFill>
                 <a:latin typeface="Arial"/>
               </a:rPr>
-              <a:t>Unbilled +169 vs 01-Aug: </a:t>
+              <a:t>Unbilled −170 vs month start: </a:t>
             </a:r>
             <a:r>
               <a:rPr sz="950" b="0" i="0">
@@ -38236,7 +38543,7 @@
                 </a:solidFill>
                 <a:latin typeface="Arial"/>
               </a:rPr>
-              <a:t>decreases AM −150, JESA Tech −137, Energy Ops −48, Global Mining −10</a:t>
+              <a:t>decreases SP2M −92, AM −33, Water &amp; Env. −28, Fert. &amp; Chem. −10</a:t>
             </a:r>
             <a:r>
               <a:rPr sz="950" b="0" i="0">
@@ -38245,7 +38552,7 @@
                 </a:solidFill>
                 <a:latin typeface="Arial"/>
               </a:rPr>
-              <a:t>; increases SP2M +292, Water &amp; Env. +169, B&amp;I +41</a:t>
+              <a:t/>
             </a:r>
           </a:p>
           <a:p>
@@ -38261,7 +38568,7 @@
                 </a:solidFill>
                 <a:latin typeface="Arial"/>
               </a:rPr>
-              <a:t>Unpaid −764 vs 01-Aug: </a:t>
+              <a:t>Unpaid +6 vs month start: </a:t>
             </a:r>
             <a:r>
               <a:rPr sz="950" b="0" i="0">
@@ -38270,7 +38577,7 @@
                 </a:solidFill>
                 <a:latin typeface="Arial"/>
               </a:rPr>
-              <a:t>decreases Water &amp; Env. −785, SP2M −177, Energy Ops −38</a:t>
+              <a:t>decreases AM −11, Global Mining −6, Energy Ops −2</a:t>
             </a:r>
             <a:r>
               <a:rPr sz="950" b="0" i="0">
@@ -38279,7 +38586,7 @@
                 </a:solidFill>
                 <a:latin typeface="Arial"/>
               </a:rPr>
-              <a:t>; increases AM +109, JESA Tech +69, Fert. &amp; Chem. +32</a:t>
+              <a:t>; increases Fert. &amp; Chem. +18, Advisory +4, B&amp;I +1</a:t>
             </a:r>
           </a:p>
           <a:p>
@@ -38295,7 +38602,7 @@
                 </a:solidFill>
                 <a:latin typeface="Arial"/>
               </a:rPr>
-              <a:t>Total AR −551 vs 01-Aug: </a:t>
+              <a:t>Total AR −164 vs month start: </a:t>
             </a:r>
             <a:r>
               <a:rPr sz="950" b="0" i="0">
@@ -38304,7 +38611,7 @@
                 </a:solidFill>
                 <a:latin typeface="Arial"/>
               </a:rPr>
-              <a:t>decreases Water &amp; Env. −575, Energy Ops −86, JESA Tech −64, AM −42</a:t>
+              <a:t>decreases SP2M −92, AM −44, Water &amp; Env. −28, Global Mining −6</a:t>
             </a:r>
             <a:r>
               <a:rPr sz="950" b="0" i="0">
@@ -38313,7 +38620,7 @@
                 </a:solidFill>
                 <a:latin typeface="Arial"/>
               </a:rPr>
-              <a:t>; increases SP2M +115, Fert. &amp; Chem. +46, B&amp;I +42</a:t>
+              <a:t>; increases Fert. &amp; Chem. +8</a:t>
             </a:r>
           </a:p>
         </p:txBody>
@@ -38420,7 +38727,8 @@
                           </a:solidFill>
                           <a:latin typeface="Arial"/>
                         </a:rPr>
-                        <a:t>01-Aug</a:t>
+                        <a:t>M. start
+07-Oct</a:t>
                       </a:r>
                     </a:p>
                   </a:txBody>
@@ -38520,7 +38828,8 @@
                           </a:solidFill>
                           <a:latin typeface="Arial"/>
                         </a:rPr>
-                        <a:t>Δ vs 01-Aug</a:t>
+                        <a:t>Δ vs
+m. start</a:t>
                       </a:r>
                     </a:p>
                   </a:txBody>
@@ -38572,7 +38881,7 @@
                           </a:solidFill>
                           <a:latin typeface="Arial"/>
                         </a:rPr>
-                        <a:t>22</a:t>
+                        <a:t>21</a:t>
                       </a:r>
                     </a:p>
                   </a:txBody>
@@ -38668,11 +38977,11 @@
                       <a:r>
                         <a:rPr sz="900" b="0">
                           <a:solidFill>
-                            <a:srgbClr val="2E7D4F"/>
-                          </a:solidFill>
-                          <a:latin typeface="Arial"/>
-                        </a:rPr>
-                        <a:t>−1</a:t>
+                            <a:srgbClr val="7A8794"/>
+                          </a:solidFill>
+                          <a:latin typeface="Arial"/>
+                        </a:rPr>
+                        <a:t>0</a:t>
                       </a:r>
                     </a:p>
                   </a:txBody>
@@ -38724,7 +39033,7 @@
                           </a:solidFill>
                           <a:latin typeface="Arial"/>
                         </a:rPr>
-                        <a:t>65</a:t>
+                        <a:t>67</a:t>
                       </a:r>
                     </a:p>
                   </a:txBody>
@@ -38820,11 +39129,11 @@
                       <a:r>
                         <a:rPr sz="900" b="0">
                           <a:solidFill>
-                            <a:srgbClr val="B5473A"/>
-                          </a:solidFill>
-                          <a:latin typeface="Arial"/>
-                        </a:rPr>
-                        <a:t>+2</a:t>
+                            <a:srgbClr val="7A8794"/>
+                          </a:solidFill>
+                          <a:latin typeface="Arial"/>
+                        </a:rPr>
+                        <a:t>0</a:t>
                       </a:r>
                     </a:p>
                   </a:txBody>
@@ -38876,7 +39185,7 @@
                           </a:solidFill>
                           <a:latin typeface="Arial"/>
                         </a:rPr>
-                        <a:t>228</a:t>
+                        <a:t>276</a:t>
                       </a:r>
                     </a:p>
                   </a:txBody>
@@ -38972,11 +39281,11 @@
                       <a:r>
                         <a:rPr sz="900" b="0">
                           <a:solidFill>
-                            <a:srgbClr val="B5473A"/>
-                          </a:solidFill>
-                          <a:latin typeface="Arial"/>
-                        </a:rPr>
-                        <a:t>+48</a:t>
+                            <a:srgbClr val="7A8794"/>
+                          </a:solidFill>
+                          <a:latin typeface="Arial"/>
+                        </a:rPr>
+                        <a:t>0</a:t>
                       </a:r>
                     </a:p>
                   </a:txBody>
@@ -39028,7 +39337,7 @@
                           </a:solidFill>
                           <a:latin typeface="Arial"/>
                         </a:rPr>
-                        <a:t>5,225</a:t>
+                        <a:t>4,212</a:t>
                       </a:r>
                     </a:p>
                   </a:txBody>
@@ -39128,7 +39437,7 @@
                           </a:solidFill>
                           <a:latin typeface="Arial"/>
                         </a:rPr>
-                        <a:t>−1,021</a:t>
+                        <a:t>−7</a:t>
                       </a:r>
                     </a:p>
                   </a:txBody>
@@ -39180,7 +39489,7 @@
                           </a:solidFill>
                           <a:latin typeface="Arial"/>
                         </a:rPr>
-                        <a:t>7,700</a:t>
+                        <a:t>8,277</a:t>
                       </a:r>
                     </a:p>
                   </a:txBody>
@@ -39276,11 +39585,11 @@
                       <a:r>
                         <a:rPr sz="900" b="0">
                           <a:solidFill>
-                            <a:srgbClr val="B5473A"/>
-                          </a:solidFill>
-                          <a:latin typeface="Arial"/>
-                        </a:rPr>
-                        <a:t>+421</a:t>
+                            <a:srgbClr val="2E7D4F"/>
+                          </a:solidFill>
+                          <a:latin typeface="Arial"/>
+                        </a:rPr>
+                        <a:t>−156</a:t>
                       </a:r>
                     </a:p>
                   </a:txBody>
@@ -39332,7 +39641,7 @@
                           </a:solidFill>
                           <a:latin typeface="Arial"/>
                         </a:rPr>
-                        <a:t>13,240</a:t>
+                        <a:t>12,853</a:t>
                       </a:r>
                     </a:p>
                   </a:txBody>
@@ -39432,7 +39741,7 @@
                           </a:solidFill>
                           <a:latin typeface="Arial"/>
                         </a:rPr>
-                        <a:t>−551</a:t>
+                        <a:t>−164</a:t>
                       </a:r>
                     </a:p>
                   </a:txBody>
@@ -39679,7 +39988,7 @@
                 </a:solidFill>
                 <a:latin typeface="Arial"/>
               </a:rPr>
-              <a:t>Total AR by BU: this week vs last week and vs the 01-Aug baseline (MMAD)</a:t>
+              <a:t>Total AR by BU: this week vs last week and vs the month-start baseline (07-Oct) (MMAD)</a:t>
             </a:r>
           </a:p>
         </p:txBody>
@@ -39828,8 +40137,8 @@
                           </a:solidFill>
                           <a:latin typeface="Arial"/>
                         </a:rPr>
-                        <a:t>Total AR
-01-Aug</a:t>
+                        <a:t>Month start
+07-Oct</a:t>
                       </a:r>
                     </a:p>
                   </a:txBody>
@@ -39854,7 +40163,7 @@
                           </a:solidFill>
                           <a:latin typeface="Arial"/>
                         </a:rPr>
-                        <a:t>Total AR
+                        <a:t>Last week
 07-Oct</a:t>
                       </a:r>
                     </a:p>
@@ -39880,7 +40189,7 @@
                           </a:solidFill>
                           <a:latin typeface="Arial"/>
                         </a:rPr>
-                        <a:t>Total AR
+                        <a:t>This week
 14-Oct</a:t>
                       </a:r>
                     </a:p>
@@ -39931,7 +40240,8 @@
                           </a:solidFill>
                           <a:latin typeface="Arial"/>
                         </a:rPr>
-                        <a:t>Δ vs 01-Aug</a:t>
+                        <a:t>Δ vs
+month start</a:t>
                       </a:r>
                     </a:p>
                   </a:txBody>
@@ -40160,7 +40470,7 @@
                           </a:solidFill>
                           <a:latin typeface="Arial"/>
                         </a:rPr>
-                        <a:t>4,078</a:t>
+                        <a:t>3,531</a:t>
                       </a:r>
                     </a:p>
                   </a:txBody>
@@ -40260,7 +40570,7 @@
                           </a:solidFill>
                           <a:latin typeface="Arial"/>
                         </a:rPr>
-                        <a:t>−575</a:t>
+                        <a:t>−28</a:t>
                       </a:r>
                     </a:p>
                   </a:txBody>
@@ -40410,7 +40720,7 @@
                           </a:solidFill>
                           <a:latin typeface="Arial"/>
                         </a:rPr>
-                        <a:t>1,513</a:t>
+                        <a:t>1,511</a:t>
                       </a:r>
                     </a:p>
                   </a:txBody>
@@ -40435,7 +40745,7 @@
                           </a:solidFill>
                           <a:latin typeface="Arial"/>
                         </a:rPr>
-                        <a:t>5,016</a:t>
+                        <a:t>5,015</a:t>
                       </a:r>
                     </a:p>
                   </a:txBody>
@@ -40487,7 +40797,7 @@
                           </a:solidFill>
                           <a:latin typeface="Arial"/>
                         </a:rPr>
-                        <a:t>3,197</a:t>
+                        <a:t>3,234</a:t>
                       </a:r>
                     </a:p>
                   </a:txBody>
@@ -40587,7 +40897,7 @@
                           </a:solidFill>
                           <a:latin typeface="Arial"/>
                         </a:rPr>
-                        <a:t>+46</a:t>
+                        <a:t>+8</a:t>
                       </a:r>
                     </a:p>
                   </a:txBody>
@@ -40737,7 +41047,7 @@
                           </a:solidFill>
                           <a:latin typeface="Arial"/>
                         </a:rPr>
-                        <a:t>1,387</a:t>
+                        <a:t>1,382</a:t>
                       </a:r>
                     </a:p>
                   </a:txBody>
@@ -40762,7 +41072,7 @@
                           </a:solidFill>
                           <a:latin typeface="Arial"/>
                         </a:rPr>
-                        <a:t>4,629</a:t>
+                        <a:t>4,624</a:t>
                       </a:r>
                     </a:p>
                   </a:txBody>
@@ -40814,7 +41124,7 @@
                           </a:solidFill>
                           <a:latin typeface="Arial"/>
                         </a:rPr>
-                        <a:t>3,121</a:t>
+                        <a:t>3,328</a:t>
                       </a:r>
                     </a:p>
                   </a:txBody>
@@ -40914,7 +41224,7 @@
                           </a:solidFill>
                           <a:latin typeface="Arial"/>
                         </a:rPr>
-                        <a:t>+115</a:t>
+                        <a:t>−92</a:t>
                       </a:r>
                     </a:p>
                   </a:txBody>
@@ -41064,7 +41374,7 @@
                           </a:solidFill>
                           <a:latin typeface="Arial"/>
                         </a:rPr>
-                        <a:t>3,670</a:t>
+                        <a:t>3,271</a:t>
                       </a:r>
                     </a:p>
                   </a:txBody>
@@ -41089,7 +41399,7 @@
                           </a:solidFill>
                           <a:latin typeface="Arial"/>
                         </a:rPr>
-                        <a:t>6,907</a:t>
+                        <a:t>6,507</a:t>
                       </a:r>
                     </a:p>
                   </a:txBody>
@@ -41141,7 +41451,7 @@
                           </a:solidFill>
                           <a:latin typeface="Arial"/>
                         </a:rPr>
-                        <a:t>1,018</a:t>
+                        <a:t>1,020</a:t>
                       </a:r>
                     </a:p>
                   </a:txBody>
@@ -41241,7 +41551,7 @@
                           </a:solidFill>
                           <a:latin typeface="Arial"/>
                         </a:rPr>
-                        <a:t>−42</a:t>
+                        <a:t>−44</a:t>
                       </a:r>
                     </a:p>
                   </a:txBody>
@@ -41391,7 +41701,7 @@
                           </a:solidFill>
                           <a:latin typeface="Arial"/>
                         </a:rPr>
-                        <a:t>127</a:t>
+                        <a:t>132</a:t>
                       </a:r>
                     </a:p>
                   </a:txBody>
@@ -41416,7 +41726,7 @@
                           </a:solidFill>
                           <a:latin typeface="Arial"/>
                         </a:rPr>
-                        <a:t>1,103</a:t>
+                        <a:t>1,109</a:t>
                       </a:r>
                     </a:p>
                   </a:txBody>
@@ -41468,7 +41778,7 @@
                           </a:solidFill>
                           <a:latin typeface="Arial"/>
                         </a:rPr>
-                        <a:t>583</a:t>
+                        <a:t>500</a:t>
                       </a:r>
                     </a:p>
                   </a:txBody>
@@ -41568,7 +41878,7 @@
                           </a:solidFill>
                           <a:latin typeface="Arial"/>
                         </a:rPr>
-                        <a:t>−86</a:t>
+                        <a:t>−2</a:t>
                       </a:r>
                     </a:p>
                   </a:txBody>
@@ -41795,7 +42105,7 @@
                           </a:solidFill>
                           <a:latin typeface="Arial"/>
                         </a:rPr>
-                        <a:t>539</a:t>
+                        <a:t>557</a:t>
                       </a:r>
                     </a:p>
                   </a:txBody>
@@ -41895,7 +42205,7 @@
                           </a:solidFill>
                           <a:latin typeface="Arial"/>
                         </a:rPr>
-                        <a:t>+12</a:t>
+                        <a:t>−6</a:t>
                       </a:r>
                     </a:p>
                   </a:txBody>
@@ -42045,7 +42355,7 @@
                           </a:solidFill>
                           <a:latin typeface="Arial"/>
                         </a:rPr>
-                        <a:t>228</a:t>
+                        <a:t>160</a:t>
                       </a:r>
                     </a:p>
                   </a:txBody>
@@ -42070,7 +42380,7 @@
                           </a:solidFill>
                           <a:latin typeface="Arial"/>
                         </a:rPr>
-                        <a:t>779</a:t>
+                        <a:t>712</a:t>
                       </a:r>
                     </a:p>
                   </a:txBody>
@@ -42122,7 +42432,7 @@
                           </a:solidFill>
                           <a:latin typeface="Arial"/>
                         </a:rPr>
-                        <a:t>444</a:t>
+                        <a:t>487</a:t>
                       </a:r>
                     </a:p>
                   </a:txBody>
@@ -42222,7 +42532,7 @@
                           </a:solidFill>
                           <a:latin typeface="Arial"/>
                         </a:rPr>
-                        <a:t>+42</a:t>
+                        <a:t>−1</a:t>
                       </a:r>
                     </a:p>
                   </a:txBody>
@@ -42372,7 +42682,7 @@
                           </a:solidFill>
                           <a:latin typeface="Arial"/>
                         </a:rPr>
-                        <a:t>53</a:t>
+                        <a:t>58</a:t>
                       </a:r>
                     </a:p>
                   </a:txBody>
@@ -42397,7 +42707,7 @@
                           </a:solidFill>
                           <a:latin typeface="Arial"/>
                         </a:rPr>
-                        <a:t>540</a:t>
+                        <a:t>545</a:t>
                       </a:r>
                     </a:p>
                   </a:txBody>
@@ -42449,7 +42759,7 @@
                           </a:solidFill>
                           <a:latin typeface="Arial"/>
                         </a:rPr>
-                        <a:t>179</a:t>
+                        <a:t>115</a:t>
                       </a:r>
                     </a:p>
                   </a:txBody>
@@ -42549,7 +42859,7 @@
                           </a:solidFill>
                           <a:latin typeface="Arial"/>
                         </a:rPr>
-                        <a:t>−64</a:t>
+                        <a:t>0</a:t>
                       </a:r>
                     </a:p>
                   </a:txBody>
@@ -42776,7 +43086,7 @@
                           </a:solidFill>
                           <a:latin typeface="Arial"/>
                         </a:rPr>
-                        <a:t>75</a:t>
+                        <a:t>73</a:t>
                       </a:r>
                     </a:p>
                   </a:txBody>
@@ -42876,7 +43186,7 @@
                           </a:solidFill>
                           <a:latin typeface="Arial"/>
                         </a:rPr>
-                        <a:t>−1</a:t>
+                        <a:t>+1</a:t>
                       </a:r>
                     </a:p>
                   </a:txBody>
@@ -43103,7 +43413,7 @@
                           </a:solidFill>
                           <a:latin typeface="Arial"/>
                         </a:rPr>
-                        <a:t>6</a:t>
+                        <a:t>7</a:t>
                       </a:r>
                     </a:p>
                   </a:txBody>
@@ -43203,7 +43513,7 @@
                           </a:solidFill>
                           <a:latin typeface="Arial"/>
                         </a:rPr>
-                        <a:t>+1</a:t>
+                        <a:t>0</a:t>
                       </a:r>
                     </a:p>
                   </a:txBody>
@@ -43430,7 +43740,7 @@
                           </a:solidFill>
                           <a:latin typeface="Arial"/>
                         </a:rPr>
-                        <a:t>13,240</a:t>
+                        <a:t>12,853</a:t>
                       </a:r>
                     </a:p>
                   </a:txBody>
@@ -43530,7 +43840,7 @@
                           </a:solidFill>
                           <a:latin typeface="Arial"/>
                         </a:rPr>
-                        <a:t>−551</a:t>
+                        <a:t>−164</a:t>
                       </a:r>
                     </a:p>
                   </a:txBody>
@@ -43680,7 +43990,7 @@
                           </a:solidFill>
                           <a:latin typeface="Arial"/>
                         </a:rPr>
-                        <a:t>7,592</a:t>
+                        <a:t>7,128</a:t>
                       </a:r>
                     </a:p>
                   </a:txBody>
@@ -43705,7 +44015,7 @@
                           </a:solidFill>
                           <a:latin typeface="Arial"/>
                         </a:rPr>
-                        <a:t>20,281</a:t>
+                        <a:t>19,817</a:t>
                       </a:r>
                     </a:p>
                   </a:txBody>
@@ -44148,7 +44458,8 @@
                           </a:solidFill>
                           <a:latin typeface="Arial"/>
                         </a:rPr>
-                        <a:t>01-Aug</a:t>
+                        <a:t>M. start
+07-Oct</a:t>
                       </a:r>
                     </a:p>
                   </a:txBody>
@@ -44273,7 +44584,8 @@
                           </a:solidFill>
                           <a:latin typeface="Arial"/>
                         </a:rPr>
-                        <a:t>Δ vs 01-Aug</a:t>
+                        <a:t>Δ vs
+m. start</a:t>
                       </a:r>
                     </a:p>
                   </a:txBody>
@@ -44325,7 +44637,7 @@
                           </a:solidFill>
                           <a:latin typeface="Arial"/>
                         </a:rPr>
-                        <a:t>8,259</a:t>
+                        <a:t>7,154</a:t>
                       </a:r>
                     </a:p>
                   </a:txBody>
@@ -44450,7 +44762,7 @@
                           </a:solidFill>
                           <a:latin typeface="Arial"/>
                         </a:rPr>
-                        <a:t>−1,160</a:t>
+                        <a:t>−55</a:t>
                       </a:r>
                     </a:p>
                   </a:txBody>
@@ -44502,7 +44814,7 @@
                           </a:solidFill>
                           <a:latin typeface="Arial"/>
                         </a:rPr>
-                        <a:t>0</a:t>
+                        <a:t>1,389</a:t>
                       </a:r>
                     </a:p>
                   </a:txBody>
@@ -44627,7 +44939,7 @@
                           </a:solidFill>
                           <a:latin typeface="Arial"/>
                         </a:rPr>
-                        <a:t>+1,389</a:t>
+                        <a:t>+1</a:t>
                       </a:r>
                     </a:p>
                   </a:txBody>
@@ -44679,7 +44991,7 @@
                           </a:solidFill>
                           <a:latin typeface="Arial"/>
                         </a:rPr>
-                        <a:t>856</a:t>
+                        <a:t>928</a:t>
                       </a:r>
                     </a:p>
                   </a:txBody>
@@ -44804,7 +45116,7 @@
                           </a:solidFill>
                           <a:latin typeface="Arial"/>
                         </a:rPr>
-                        <a:t>−42</a:t>
+                        <a:t>−114</a:t>
                       </a:r>
                     </a:p>
                   </a:txBody>
@@ -44856,7 +45168,7 @@
                           </a:solidFill>
                           <a:latin typeface="Arial"/>
                         </a:rPr>
-                        <a:t>207</a:t>
+                        <a:t>213</a:t>
                       </a:r>
                     </a:p>
                   </a:txBody>
@@ -44977,11 +45289,11 @@
                       <a:r>
                         <a:rPr sz="950" b="0">
                           <a:solidFill>
-                            <a:srgbClr val="B5473A"/>
-                          </a:solidFill>
-                          <a:latin typeface="Arial"/>
-                        </a:rPr>
-                        <a:t>+5</a:t>
+                            <a:srgbClr val="2E7D4F"/>
+                          </a:solidFill>
+                          <a:latin typeface="Arial"/>
+                        </a:rPr>
+                        <a:t>−1</a:t>
                       </a:r>
                     </a:p>
                   </a:txBody>
@@ -45033,7 +45345,7 @@
                           </a:solidFill>
                           <a:latin typeface="Arial"/>
                         </a:rPr>
-                        <a:t>9,345</a:t>
+                        <a:t>9,684</a:t>
                       </a:r>
                     </a:p>
                   </a:txBody>
@@ -45158,7 +45470,7 @@
                           </a:solidFill>
                           <a:latin typeface="Arial"/>
                         </a:rPr>
-                        <a:t>+169</a:t>
+                        <a:t>−170</a:t>
                       </a:r>
                     </a:p>
                   </a:txBody>
@@ -46610,7 +46922,8 @@
                           </a:solidFill>
                           <a:latin typeface="Arial"/>
                         </a:rPr>
-                        <a:t>01-Aug</a:t>
+                        <a:t>M. start
+07-Oct</a:t>
                       </a:r>
                     </a:p>
                   </a:txBody>
@@ -46735,7 +47048,8 @@
                           </a:solidFill>
                           <a:latin typeface="Arial"/>
                         </a:rPr>
-                        <a:t>Δ vs 01-Aug</a:t>
+                        <a:t>Δ vs
+m. start</a:t>
                       </a:r>
                     </a:p>
                   </a:txBody>
@@ -46787,7 +47101,7 @@
                           </a:solidFill>
                           <a:latin typeface="Arial"/>
                         </a:rPr>
-                        <a:t>837</a:t>
+                        <a:t>261</a:t>
                       </a:r>
                     </a:p>
                   </a:txBody>
@@ -46908,11 +47222,11 @@
                       <a:r>
                         <a:rPr sz="950" b="0">
                           <a:solidFill>
-                            <a:srgbClr val="2E7D4F"/>
-                          </a:solidFill>
-                          <a:latin typeface="Arial"/>
-                        </a:rPr>
-                        <a:t>−547</a:t>
+                            <a:srgbClr val="B5473A"/>
+                          </a:solidFill>
+                          <a:latin typeface="Arial"/>
+                        </a:rPr>
+                        <a:t>+29</a:t>
                       </a:r>
                     </a:p>
                   </a:txBody>
@@ -46964,7 +47278,7 @@
                           </a:solidFill>
                           <a:latin typeface="Arial"/>
                         </a:rPr>
-                        <a:t>841</a:t>
+                        <a:t>430</a:t>
                       </a:r>
                     </a:p>
                   </a:txBody>
@@ -47085,11 +47399,11 @@
                       <a:r>
                         <a:rPr sz="950" b="0">
                           <a:solidFill>
-                            <a:srgbClr val="2E7D4F"/>
-                          </a:solidFill>
-                          <a:latin typeface="Arial"/>
-                        </a:rPr>
-                        <a:t>−369</a:t>
+                            <a:srgbClr val="B5473A"/>
+                          </a:solidFill>
+                          <a:latin typeface="Arial"/>
+                        </a:rPr>
+                        <a:t>+42</a:t>
                       </a:r>
                     </a:p>
                   </a:txBody>
@@ -47141,7 +47455,7 @@
                           </a:solidFill>
                           <a:latin typeface="Arial"/>
                         </a:rPr>
-                        <a:t>318</a:t>
+                        <a:t>185</a:t>
                       </a:r>
                     </a:p>
                   </a:txBody>
@@ -47266,7 +47580,7 @@
                           </a:solidFill>
                           <a:latin typeface="Arial"/>
                         </a:rPr>
-                        <a:t>−170</a:t>
+                        <a:t>−38</a:t>
                       </a:r>
                     </a:p>
                   </a:txBody>
@@ -47318,7 +47632,7 @@
                           </a:solidFill>
                           <a:latin typeface="Arial"/>
                         </a:rPr>
-                        <a:t>380</a:t>
+                        <a:t>829</a:t>
                       </a:r>
                     </a:p>
                   </a:txBody>
@@ -47439,11 +47753,11 @@
                       <a:r>
                         <a:rPr sz="950" b="0">
                           <a:solidFill>
-                            <a:srgbClr val="B5473A"/>
-                          </a:solidFill>
-                          <a:latin typeface="Arial"/>
-                        </a:rPr>
-                        <a:t>+404</a:t>
+                            <a:srgbClr val="2E7D4F"/>
+                          </a:solidFill>
+                          <a:latin typeface="Arial"/>
+                        </a:rPr>
+                        <a:t>−45</a:t>
                       </a:r>
                     </a:p>
                   </a:txBody>
@@ -47495,7 +47809,7 @@
                           </a:solidFill>
                           <a:latin typeface="Arial"/>
                         </a:rPr>
-                        <a:t>339</a:t>
+                        <a:t>351</a:t>
                       </a:r>
                     </a:p>
                   </a:txBody>
@@ -47620,7 +47934,7 @@
                           </a:solidFill>
                           <a:latin typeface="Arial"/>
                         </a:rPr>
-                        <a:t>+14</a:t>
+                        <a:t>+2</a:t>
                       </a:r>
                     </a:p>
                   </a:txBody>
@@ -47672,7 +47986,7 @@
                           </a:solidFill>
                           <a:latin typeface="Arial"/>
                         </a:rPr>
-                        <a:t>677</a:t>
+                        <a:t>566</a:t>
                       </a:r>
                     </a:p>
                   </a:txBody>
@@ -47793,11 +48107,11 @@
                       <a:r>
                         <a:rPr sz="950" b="0">
                           <a:solidFill>
-                            <a:srgbClr val="2E7D4F"/>
-                          </a:solidFill>
-                          <a:latin typeface="Arial"/>
-                        </a:rPr>
-                        <a:t>−95</a:t>
+                            <a:srgbClr val="B5473A"/>
+                          </a:solidFill>
+                          <a:latin typeface="Arial"/>
+                        </a:rPr>
+                        <a:t>+16</a:t>
                       </a:r>
                     </a:p>
                   </a:txBody>
@@ -47849,7 +48163,7 @@
                           </a:solidFill>
                           <a:latin typeface="Arial"/>
                         </a:rPr>
-                        <a:t>3,391</a:t>
+                        <a:t>2,622</a:t>
                       </a:r>
                     </a:p>
                   </a:txBody>
@@ -47974,7 +48288,7 @@
                           </a:solidFill>
                           <a:latin typeface="Arial"/>
                         </a:rPr>
-                        <a:t>−764</a:t>
+                        <a:t>+6</a:t>
                       </a:r>
                     </a:p>
                   </a:txBody>
@@ -48221,7 +48535,7 @@
                 </a:solidFill>
                 <a:latin typeface="Arial"/>
               </a:rPr>
-              <a:t>Unrecognized revenue of 7,592 MMAD (+40 WoW): executed scope not yet booked as AR, incl. JESA cost + fee</a:t>
+              <a:t>Unrecognized revenue of 7,128 MMAD incl. markup (−666 vs the previous BU update): executed scope not yet booked as AR</a:t>
             </a:r>
           </a:p>
         </p:txBody>
@@ -48372,7 +48686,7 @@
                 </a:solidFill>
                 <a:latin typeface="Arial"/>
               </a:rPr>
-              <a:t>UNRECOGNIZED REVENUE</a:t>
+              <a:t>UNRECOGNIZED REVENUE (INCL. JESA COST + FEE)</a:t>
             </a:r>
           </a:p>
         </p:txBody>
@@ -48407,7 +48721,7 @@
                 </a:solidFill>
                 <a:latin typeface="Arial"/>
               </a:rPr>
-              <a:t>7,592  MMAD</a:t>
+              <a:t>7,128  MMAD</a:t>
             </a:r>
           </a:p>
         </p:txBody>
@@ -48442,7 +48756,7 @@
                 </a:solidFill>
                 <a:latin typeface="Arial"/>
               </a:rPr>
-              <a:t>Supplier scope incl. JESA cost + fee  ·  +40 vs last week</a:t>
+              <a:t>Supplier scope 7,100 + lines to be adjusted 28  ·  previous BU update 7,794</a:t>
             </a:r>
           </a:p>
         </p:txBody>
@@ -48523,7 +48837,7 @@
                 </a:solidFill>
                 <a:latin typeface="Arial"/>
               </a:rPr>
-              <a:t>UNRECOGNIZED SUPPLIERS – COST</a:t>
+              <a:t>SUPPLIER PO BOOK</a:t>
             </a:r>
           </a:p>
         </p:txBody>
@@ -48537,7 +48851,7 @@
         <p:spPr>
           <a:xfrm>
             <a:off x="6263640" y="1463040"/>
-            <a:ext cx="5532120" cy="441960"/>
+            <a:ext cx="5532120" cy="408940"/>
           </a:xfrm>
           <a:prstGeom prst="rect">
             <a:avLst/>
@@ -48552,13 +48866,13 @@
           <a:p>
             <a:pPr algn="l"/>
             <a:r>
-              <a:rPr sz="2400" b="1" i="0">
+              <a:rPr sz="2200" b="1" i="0">
                 <a:solidFill>
                   <a:srgbClr val="FFFFFF"/>
                 </a:solidFill>
                 <a:latin typeface="Arial"/>
               </a:rPr>
-              <a:t>6,212  MMAD</a:t>
+              <a:t>21,831  MMAD contract value</a:t>
             </a:r>
           </a:p>
         </p:txBody>
@@ -48593,7 +48907,7 @@
                 </a:solidFill>
                 <a:latin typeface="Arial"/>
               </a:rPr>
-              <a:t>Executed but unbooked supplier &amp; equipment scope (HT, excl. DP) before adjustments</a:t>
+              <a:t>Recognized (SAP GR) 10,694  ·  unrecognized 4,485  ·  remaining to execute 6,653</a:t>
             </a:r>
           </a:p>
         </p:txBody>
@@ -48606,7 +48920,7 @@
         </p:nvSpPr>
         <p:spPr>
           <a:xfrm>
-            <a:off x="365760" y="2286000"/>
+            <a:off x="365760" y="2331720"/>
             <a:ext cx="5486400" cy="274320"/>
           </a:xfrm>
           <a:prstGeom prst="rect">
@@ -48622,13 +48936,13 @@
           <a:p>
             <a:pPr algn="l"/>
             <a:r>
-              <a:rPr sz="1300" b="1" i="0">
+              <a:rPr sz="1250" b="1" i="0">
                 <a:solidFill>
                   <a:srgbClr val="1B2F4B"/>
                 </a:solidFill>
                 <a:latin typeface="Arial"/>
               </a:rPr>
-              <a:t>Unrecognized revenue by business unit (MMAD)</a:t>
+              <a:t>By business unit – previous BU update vs current (MMAD)</a:t>
             </a:r>
           </a:p>
         </p:txBody>
@@ -48642,8 +48956,8 @@
           <p:nvPr/>
         </p:nvGraphicFramePr>
         <p:xfrm>
-          <a:off x="274320" y="2560320"/>
-          <a:ext cx="5669280" cy="3931920"/>
+          <a:off x="274320" y="2606040"/>
+          <a:ext cx="5669280" cy="3886200"/>
         </p:xfrm>
         <a:graphic>
           <a:graphicData uri="http://schemas.openxmlformats.org/drawingml/2006/chart">
@@ -48659,7 +48973,7 @@
         </p:nvSpPr>
         <p:spPr>
           <a:xfrm>
-            <a:off x="6172200" y="2286000"/>
+            <a:off x="6172200" y="2331720"/>
             <a:ext cx="5669280" cy="274320"/>
           </a:xfrm>
           <a:prstGeom prst="rect">
@@ -48675,7 +48989,7 @@
           <a:p>
             <a:pPr algn="l"/>
             <a:r>
-              <a:rPr sz="1300" b="1" i="0">
+              <a:rPr sz="1250" b="1" i="0">
                 <a:solidFill>
                   <a:srgbClr val="1B2F4B"/>
                 </a:solidFill>
@@ -48695,8 +49009,8 @@
           <p:nvPr/>
         </p:nvGraphicFramePr>
         <p:xfrm>
-          <a:off x="6080760" y="2560320"/>
-          <a:ext cx="5852160" cy="2651760"/>
+          <a:off x="6080760" y="2606040"/>
+          <a:ext cx="5852160" cy="2148840"/>
         </p:xfrm>
         <a:graphic>
           <a:graphicData uri="http://schemas.openxmlformats.org/drawingml/2006/chart">
@@ -48712,8 +49026,8 @@
         </p:nvSpPr>
         <p:spPr>
           <a:xfrm>
-            <a:off x="6172200" y="5257800"/>
-            <a:ext cx="5669280" cy="1188720"/>
+            <a:off x="6172200" y="4800600"/>
+            <a:ext cx="5669280" cy="274320"/>
           </a:xfrm>
           <a:prstGeom prst="rect">
             <a:avLst/>
@@ -48726,48 +49040,1064 @@
           </a:bodyPr>
           <a:lstStyle/>
           <a:p>
-            <a:pPr algn="l">
-              <a:lnSpc>
-                <a:spcPct val="110000"/>
-              </a:lnSpc>
-            </a:pPr>
+            <a:pPr algn="l"/>
             <a:r>
-              <a:rPr sz="950" b="1" i="0">
+              <a:rPr sz="1100" b="1" i="0">
                 <a:solidFill>
                   <a:srgbClr val="1B2F4B"/>
                 </a:solidFill>
                 <a:latin typeface="Arial"/>
               </a:rPr>
-              <a:t>Reading: </a:t>
-            </a:r>
-            <a:r>
-              <a:rPr sz="950" b="0" i="0">
-                <a:solidFill>
-                  <a:srgbClr val="1F2A37"/>
-                </a:solidFill>
-                <a:latin typeface="Arial"/>
-              </a:rPr>
-              <a:t>available for submission (pending submission) 2,854 MMAD; already submitted and pending client approval 1,287 MMAD; signed by client 363 MMAD; executed under change notice 1,702 MMAD. </a:t>
-            </a:r>
-          </a:p>
-          <a:p>
-            <a:pPr algn="l">
-              <a:lnSpc>
-                <a:spcPct val="110000"/>
-              </a:lnSpc>
-            </a:pPr>
-            <a:r>
-              <a:rPr sz="950" b="0" i="1">
-                <a:solidFill>
-                  <a:srgbClr val="B5473A"/>
-                </a:solidFill>
-                <a:latin typeface="Arial"/>
-              </a:rPr>
-              <a:t>Lines to be adjusted: 1,379 MMAD (mostly SP2M). Numbers remain under stabilisation by the bottom-up exercise with backup.</a:t>
+              <a:t>Supplier PO book by business unit (MMAD)</a:t>
             </a:r>
           </a:p>
         </p:txBody>
       </p:sp>
+      <p:graphicFrame>
+        <p:nvGraphicFramePr>
+          <p:cNvPr id="22" name="Table 21"/>
+          <p:cNvGraphicFramePr>
+            <a:graphicFrameLocks noGrp="1"/>
+          </p:cNvGraphicFramePr>
+          <p:nvPr/>
+        </p:nvGraphicFramePr>
+        <p:xfrm>
+          <a:off x="6172200" y="5047488"/>
+          <a:ext cx="5715000" cy="1453896"/>
+        </p:xfrm>
+        <a:graphic>
+          <a:graphicData uri="http://schemas.openxmlformats.org/drawingml/2006/table">
+            <a:tbl>
+              <a:tblPr firstRow="0" bandRow="0">
+                <a:tableStyleId>{2D5ABB26-0587-4C30-8999-92F81FD0307C}</a:tableStyleId>
+              </a:tblPr>
+              <a:tblGrid>
+                <a:gridCol w="1645920"/>
+                <a:gridCol w="1097280"/>
+                <a:gridCol w="1005840"/>
+                <a:gridCol w="1005840"/>
+                <a:gridCol w="960120"/>
+              </a:tblGrid>
+              <a:tr h="237744">
+                <a:tc>
+                  <a:txBody>
+                    <a:bodyPr wrap="square"/>
+                    <a:lstStyle/>
+                    <a:p>
+                      <a:pPr algn="l">
+                        <a:defRPr sz="800"/>
+                      </a:pPr>
+                      <a:r>
+                        <a:rPr sz="800" b="1">
+                          <a:solidFill>
+                            <a:srgbClr val="FFFFFF"/>
+                          </a:solidFill>
+                          <a:latin typeface="Arial"/>
+                        </a:rPr>
+                        <a:t>BU</a:t>
+                      </a:r>
+                    </a:p>
+                  </a:txBody>
+                  <a:tcPr marL="45720" marR="45720" marT="13716" marB="13716" anchor="ctr">
+                    <a:solidFill>
+                      <a:srgbClr val="1B2F4B"/>
+                    </a:solidFill>
+                  </a:tcPr>
+                </a:tc>
+                <a:tc>
+                  <a:txBody>
+                    <a:bodyPr wrap="square"/>
+                    <a:lstStyle/>
+                    <a:p>
+                      <a:pPr algn="ctr">
+                        <a:defRPr sz="800"/>
+                      </a:pPr>
+                      <a:r>
+                        <a:rPr sz="800" b="1">
+                          <a:solidFill>
+                            <a:srgbClr val="FFFFFF"/>
+                          </a:solidFill>
+                          <a:latin typeface="Arial"/>
+                        </a:rPr>
+                        <a:t>Contract value</a:t>
+                      </a:r>
+                    </a:p>
+                  </a:txBody>
+                  <a:tcPr marL="45720" marR="45720" marT="13716" marB="13716" anchor="ctr">
+                    <a:solidFill>
+                      <a:srgbClr val="1B2F4B"/>
+                    </a:solidFill>
+                  </a:tcPr>
+                </a:tc>
+                <a:tc>
+                  <a:txBody>
+                    <a:bodyPr wrap="square"/>
+                    <a:lstStyle/>
+                    <a:p>
+                      <a:pPr algn="ctr">
+                        <a:defRPr sz="800"/>
+                      </a:pPr>
+                      <a:r>
+                        <a:rPr sz="800" b="1">
+                          <a:solidFill>
+                            <a:srgbClr val="FFFFFF"/>
+                          </a:solidFill>
+                          <a:latin typeface="Arial"/>
+                        </a:rPr>
+                        <a:t>Recognized</a:t>
+                      </a:r>
+                    </a:p>
+                  </a:txBody>
+                  <a:tcPr marL="45720" marR="45720" marT="13716" marB="13716" anchor="ctr">
+                    <a:solidFill>
+                      <a:srgbClr val="1B2F4B"/>
+                    </a:solidFill>
+                  </a:tcPr>
+                </a:tc>
+                <a:tc>
+                  <a:txBody>
+                    <a:bodyPr wrap="square"/>
+                    <a:lstStyle/>
+                    <a:p>
+                      <a:pPr algn="ctr">
+                        <a:defRPr sz="800"/>
+                      </a:pPr>
+                      <a:r>
+                        <a:rPr sz="800" b="1">
+                          <a:solidFill>
+                            <a:srgbClr val="FFFFFF"/>
+                          </a:solidFill>
+                          <a:latin typeface="Arial"/>
+                        </a:rPr>
+                        <a:t>Unrecognized</a:t>
+                      </a:r>
+                    </a:p>
+                  </a:txBody>
+                  <a:tcPr marL="45720" marR="45720" marT="13716" marB="13716" anchor="ctr">
+                    <a:solidFill>
+                      <a:srgbClr val="1B2F4B"/>
+                    </a:solidFill>
+                  </a:tcPr>
+                </a:tc>
+                <a:tc>
+                  <a:txBody>
+                    <a:bodyPr wrap="square"/>
+                    <a:lstStyle/>
+                    <a:p>
+                      <a:pPr algn="ctr">
+                        <a:defRPr sz="800"/>
+                      </a:pPr>
+                      <a:r>
+                        <a:rPr sz="800" b="1">
+                          <a:solidFill>
+                            <a:srgbClr val="FFFFFF"/>
+                          </a:solidFill>
+                          <a:latin typeface="Arial"/>
+                        </a:rPr>
+                        <a:t>Remaining</a:t>
+                      </a:r>
+                    </a:p>
+                  </a:txBody>
+                  <a:tcPr marL="45720" marR="45720" marT="13716" marB="13716" anchor="ctr">
+                    <a:solidFill>
+                      <a:srgbClr val="1B2F4B"/>
+                    </a:solidFill>
+                  </a:tcPr>
+                </a:tc>
+              </a:tr>
+              <a:tr h="173736">
+                <a:tc>
+                  <a:txBody>
+                    <a:bodyPr wrap="square"/>
+                    <a:lstStyle/>
+                    <a:p>
+                      <a:pPr algn="l">
+                        <a:defRPr sz="800"/>
+                      </a:pPr>
+                      <a:r>
+                        <a:rPr sz="800" b="0">
+                          <a:solidFill>
+                            <a:srgbClr val="1F2A37"/>
+                          </a:solidFill>
+                          <a:latin typeface="Arial"/>
+                        </a:rPr>
+                        <a:t>SP2M</a:t>
+                      </a:r>
+                    </a:p>
+                  </a:txBody>
+                  <a:tcPr marL="45720" marR="45720" marT="13716" marB="13716" anchor="ctr">
+                    <a:solidFill>
+                      <a:srgbClr val="FFFFFF"/>
+                    </a:solidFill>
+                  </a:tcPr>
+                </a:tc>
+                <a:tc>
+                  <a:txBody>
+                    <a:bodyPr wrap="square"/>
+                    <a:lstStyle/>
+                    <a:p>
+                      <a:pPr algn="r">
+                        <a:defRPr sz="800"/>
+                      </a:pPr>
+                      <a:r>
+                        <a:rPr sz="800" b="0">
+                          <a:solidFill>
+                            <a:srgbClr val="1F2A37"/>
+                          </a:solidFill>
+                          <a:latin typeface="Arial"/>
+                        </a:rPr>
+                        <a:t>10,177</a:t>
+                      </a:r>
+                    </a:p>
+                  </a:txBody>
+                  <a:tcPr marL="45720" marR="45720" marT="13716" marB="13716" anchor="ctr">
+                    <a:solidFill>
+                      <a:srgbClr val="FFFFFF"/>
+                    </a:solidFill>
+                  </a:tcPr>
+                </a:tc>
+                <a:tc>
+                  <a:txBody>
+                    <a:bodyPr wrap="square"/>
+                    <a:lstStyle/>
+                    <a:p>
+                      <a:pPr algn="r">
+                        <a:defRPr sz="800"/>
+                      </a:pPr>
+                      <a:r>
+                        <a:rPr sz="800" b="0">
+                          <a:solidFill>
+                            <a:srgbClr val="1F2A37"/>
+                          </a:solidFill>
+                          <a:latin typeface="Arial"/>
+                        </a:rPr>
+                        <a:t>3,739</a:t>
+                      </a:r>
+                    </a:p>
+                  </a:txBody>
+                  <a:tcPr marL="45720" marR="45720" marT="13716" marB="13716" anchor="ctr">
+                    <a:solidFill>
+                      <a:srgbClr val="FFFFFF"/>
+                    </a:solidFill>
+                  </a:tcPr>
+                </a:tc>
+                <a:tc>
+                  <a:txBody>
+                    <a:bodyPr wrap="square"/>
+                    <a:lstStyle/>
+                    <a:p>
+                      <a:pPr algn="r">
+                        <a:defRPr sz="800"/>
+                      </a:pPr>
+                      <a:r>
+                        <a:rPr sz="800" b="0">
+                          <a:solidFill>
+                            <a:srgbClr val="1F2A37"/>
+                          </a:solidFill>
+                          <a:latin typeface="Arial"/>
+                        </a:rPr>
+                        <a:t>2,036</a:t>
+                      </a:r>
+                    </a:p>
+                  </a:txBody>
+                  <a:tcPr marL="45720" marR="45720" marT="13716" marB="13716" anchor="ctr">
+                    <a:solidFill>
+                      <a:srgbClr val="FFFFFF"/>
+                    </a:solidFill>
+                  </a:tcPr>
+                </a:tc>
+                <a:tc>
+                  <a:txBody>
+                    <a:bodyPr wrap="square"/>
+                    <a:lstStyle/>
+                    <a:p>
+                      <a:pPr algn="r">
+                        <a:defRPr sz="800"/>
+                      </a:pPr>
+                      <a:r>
+                        <a:rPr sz="800" b="0">
+                          <a:solidFill>
+                            <a:srgbClr val="1F2A37"/>
+                          </a:solidFill>
+                          <a:latin typeface="Arial"/>
+                        </a:rPr>
+                        <a:t>4,401</a:t>
+                      </a:r>
+                    </a:p>
+                  </a:txBody>
+                  <a:tcPr marL="45720" marR="45720" marT="13716" marB="13716" anchor="ctr">
+                    <a:solidFill>
+                      <a:srgbClr val="FFFFFF"/>
+                    </a:solidFill>
+                  </a:tcPr>
+                </a:tc>
+              </a:tr>
+              <a:tr h="173736">
+                <a:tc>
+                  <a:txBody>
+                    <a:bodyPr wrap="square"/>
+                    <a:lstStyle/>
+                    <a:p>
+                      <a:pPr algn="l">
+                        <a:defRPr sz="800"/>
+                      </a:pPr>
+                      <a:r>
+                        <a:rPr sz="800" b="0">
+                          <a:solidFill>
+                            <a:srgbClr val="1F2A37"/>
+                          </a:solidFill>
+                          <a:latin typeface="Arial"/>
+                        </a:rPr>
+                        <a:t>Water &amp; Env.</a:t>
+                      </a:r>
+                    </a:p>
+                  </a:txBody>
+                  <a:tcPr marL="45720" marR="45720" marT="13716" marB="13716" anchor="ctr">
+                    <a:solidFill>
+                      <a:srgbClr val="E9F0F6"/>
+                    </a:solidFill>
+                  </a:tcPr>
+                </a:tc>
+                <a:tc>
+                  <a:txBody>
+                    <a:bodyPr wrap="square"/>
+                    <a:lstStyle/>
+                    <a:p>
+                      <a:pPr algn="r">
+                        <a:defRPr sz="800"/>
+                      </a:pPr>
+                      <a:r>
+                        <a:rPr sz="800" b="0">
+                          <a:solidFill>
+                            <a:srgbClr val="1F2A37"/>
+                          </a:solidFill>
+                          <a:latin typeface="Arial"/>
+                        </a:rPr>
+                        <a:t>5,717</a:t>
+                      </a:r>
+                    </a:p>
+                  </a:txBody>
+                  <a:tcPr marL="45720" marR="45720" marT="13716" marB="13716" anchor="ctr">
+                    <a:solidFill>
+                      <a:srgbClr val="E9F0F6"/>
+                    </a:solidFill>
+                  </a:tcPr>
+                </a:tc>
+                <a:tc>
+                  <a:txBody>
+                    <a:bodyPr wrap="square"/>
+                    <a:lstStyle/>
+                    <a:p>
+                      <a:pPr algn="r">
+                        <a:defRPr sz="800"/>
+                      </a:pPr>
+                      <a:r>
+                        <a:rPr sz="800" b="0">
+                          <a:solidFill>
+                            <a:srgbClr val="1F2A37"/>
+                          </a:solidFill>
+                          <a:latin typeface="Arial"/>
+                        </a:rPr>
+                        <a:t>4,266</a:t>
+                      </a:r>
+                    </a:p>
+                  </a:txBody>
+                  <a:tcPr marL="45720" marR="45720" marT="13716" marB="13716" anchor="ctr">
+                    <a:solidFill>
+                      <a:srgbClr val="E9F0F6"/>
+                    </a:solidFill>
+                  </a:tcPr>
+                </a:tc>
+                <a:tc>
+                  <a:txBody>
+                    <a:bodyPr wrap="square"/>
+                    <a:lstStyle/>
+                    <a:p>
+                      <a:pPr algn="r">
+                        <a:defRPr sz="800"/>
+                      </a:pPr>
+                      <a:r>
+                        <a:rPr sz="800" b="0">
+                          <a:solidFill>
+                            <a:srgbClr val="1F2A37"/>
+                          </a:solidFill>
+                          <a:latin typeface="Arial"/>
+                        </a:rPr>
+                        <a:t>617</a:t>
+                      </a:r>
+                    </a:p>
+                  </a:txBody>
+                  <a:tcPr marL="45720" marR="45720" marT="13716" marB="13716" anchor="ctr">
+                    <a:solidFill>
+                      <a:srgbClr val="E9F0F6"/>
+                    </a:solidFill>
+                  </a:tcPr>
+                </a:tc>
+                <a:tc>
+                  <a:txBody>
+                    <a:bodyPr wrap="square"/>
+                    <a:lstStyle/>
+                    <a:p>
+                      <a:pPr algn="r">
+                        <a:defRPr sz="800"/>
+                      </a:pPr>
+                      <a:r>
+                        <a:rPr sz="800" b="0">
+                          <a:solidFill>
+                            <a:srgbClr val="1F2A37"/>
+                          </a:solidFill>
+                          <a:latin typeface="Arial"/>
+                        </a:rPr>
+                        <a:t>834</a:t>
+                      </a:r>
+                    </a:p>
+                  </a:txBody>
+                  <a:tcPr marL="45720" marR="45720" marT="13716" marB="13716" anchor="ctr">
+                    <a:solidFill>
+                      <a:srgbClr val="E9F0F6"/>
+                    </a:solidFill>
+                  </a:tcPr>
+                </a:tc>
+              </a:tr>
+              <a:tr h="173736">
+                <a:tc>
+                  <a:txBody>
+                    <a:bodyPr wrap="square"/>
+                    <a:lstStyle/>
+                    <a:p>
+                      <a:pPr algn="l">
+                        <a:defRPr sz="800"/>
+                      </a:pPr>
+                      <a:r>
+                        <a:rPr sz="800" b="0">
+                          <a:solidFill>
+                            <a:srgbClr val="1F2A37"/>
+                          </a:solidFill>
+                          <a:latin typeface="Arial"/>
+                        </a:rPr>
+                        <a:t>Fert. &amp; Chem.</a:t>
+                      </a:r>
+                    </a:p>
+                  </a:txBody>
+                  <a:tcPr marL="45720" marR="45720" marT="13716" marB="13716" anchor="ctr">
+                    <a:solidFill>
+                      <a:srgbClr val="FFFFFF"/>
+                    </a:solidFill>
+                  </a:tcPr>
+                </a:tc>
+                <a:tc>
+                  <a:txBody>
+                    <a:bodyPr wrap="square"/>
+                    <a:lstStyle/>
+                    <a:p>
+                      <a:pPr algn="r">
+                        <a:defRPr sz="800"/>
+                      </a:pPr>
+                      <a:r>
+                        <a:rPr sz="800" b="0">
+                          <a:solidFill>
+                            <a:srgbClr val="1F2A37"/>
+                          </a:solidFill>
+                          <a:latin typeface="Arial"/>
+                        </a:rPr>
+                        <a:t>3,056</a:t>
+                      </a:r>
+                    </a:p>
+                  </a:txBody>
+                  <a:tcPr marL="45720" marR="45720" marT="13716" marB="13716" anchor="ctr">
+                    <a:solidFill>
+                      <a:srgbClr val="FFFFFF"/>
+                    </a:solidFill>
+                  </a:tcPr>
+                </a:tc>
+                <a:tc>
+                  <a:txBody>
+                    <a:bodyPr wrap="square"/>
+                    <a:lstStyle/>
+                    <a:p>
+                      <a:pPr algn="r">
+                        <a:defRPr sz="800"/>
+                      </a:pPr>
+                      <a:r>
+                        <a:rPr sz="800" b="0">
+                          <a:solidFill>
+                            <a:srgbClr val="1F2A37"/>
+                          </a:solidFill>
+                          <a:latin typeface="Arial"/>
+                        </a:rPr>
+                        <a:t>1,443</a:t>
+                      </a:r>
+                    </a:p>
+                  </a:txBody>
+                  <a:tcPr marL="45720" marR="45720" marT="13716" marB="13716" anchor="ctr">
+                    <a:solidFill>
+                      <a:srgbClr val="FFFFFF"/>
+                    </a:solidFill>
+                  </a:tcPr>
+                </a:tc>
+                <a:tc>
+                  <a:txBody>
+                    <a:bodyPr wrap="square"/>
+                    <a:lstStyle/>
+                    <a:p>
+                      <a:pPr algn="r">
+                        <a:defRPr sz="800"/>
+                      </a:pPr>
+                      <a:r>
+                        <a:rPr sz="800" b="0">
+                          <a:solidFill>
+                            <a:srgbClr val="1F2A37"/>
+                          </a:solidFill>
+                          <a:latin typeface="Arial"/>
+                        </a:rPr>
+                        <a:t>982</a:t>
+                      </a:r>
+                    </a:p>
+                  </a:txBody>
+                  <a:tcPr marL="45720" marR="45720" marT="13716" marB="13716" anchor="ctr">
+                    <a:solidFill>
+                      <a:srgbClr val="FFFFFF"/>
+                    </a:solidFill>
+                  </a:tcPr>
+                </a:tc>
+                <a:tc>
+                  <a:txBody>
+                    <a:bodyPr wrap="square"/>
+                    <a:lstStyle/>
+                    <a:p>
+                      <a:pPr algn="r">
+                        <a:defRPr sz="800"/>
+                      </a:pPr>
+                      <a:r>
+                        <a:rPr sz="800" b="0">
+                          <a:solidFill>
+                            <a:srgbClr val="1F2A37"/>
+                          </a:solidFill>
+                          <a:latin typeface="Arial"/>
+                        </a:rPr>
+                        <a:t>632</a:t>
+                      </a:r>
+                    </a:p>
+                  </a:txBody>
+                  <a:tcPr marL="45720" marR="45720" marT="13716" marB="13716" anchor="ctr">
+                    <a:solidFill>
+                      <a:srgbClr val="FFFFFF"/>
+                    </a:solidFill>
+                  </a:tcPr>
+                </a:tc>
+              </a:tr>
+              <a:tr h="173736">
+                <a:tc>
+                  <a:txBody>
+                    <a:bodyPr wrap="square"/>
+                    <a:lstStyle/>
+                    <a:p>
+                      <a:pPr algn="l">
+                        <a:defRPr sz="800"/>
+                      </a:pPr>
+                      <a:r>
+                        <a:rPr sz="800" b="0">
+                          <a:solidFill>
+                            <a:srgbClr val="1F2A37"/>
+                          </a:solidFill>
+                          <a:latin typeface="Arial"/>
+                        </a:rPr>
+                        <a:t>Energy Ops</a:t>
+                      </a:r>
+                    </a:p>
+                  </a:txBody>
+                  <a:tcPr marL="45720" marR="45720" marT="13716" marB="13716" anchor="ctr">
+                    <a:solidFill>
+                      <a:srgbClr val="E9F0F6"/>
+                    </a:solidFill>
+                  </a:tcPr>
+                </a:tc>
+                <a:tc>
+                  <a:txBody>
+                    <a:bodyPr wrap="square"/>
+                    <a:lstStyle/>
+                    <a:p>
+                      <a:pPr algn="r">
+                        <a:defRPr sz="800"/>
+                      </a:pPr>
+                      <a:r>
+                        <a:rPr sz="800" b="0">
+                          <a:solidFill>
+                            <a:srgbClr val="1F2A37"/>
+                          </a:solidFill>
+                          <a:latin typeface="Arial"/>
+                        </a:rPr>
+                        <a:t>1,173</a:t>
+                      </a:r>
+                    </a:p>
+                  </a:txBody>
+                  <a:tcPr marL="45720" marR="45720" marT="13716" marB="13716" anchor="ctr">
+                    <a:solidFill>
+                      <a:srgbClr val="E9F0F6"/>
+                    </a:solidFill>
+                  </a:tcPr>
+                </a:tc>
+                <a:tc>
+                  <a:txBody>
+                    <a:bodyPr wrap="square"/>
+                    <a:lstStyle/>
+                    <a:p>
+                      <a:pPr algn="r">
+                        <a:defRPr sz="800"/>
+                      </a:pPr>
+                      <a:r>
+                        <a:rPr sz="800" b="0">
+                          <a:solidFill>
+                            <a:srgbClr val="1F2A37"/>
+                          </a:solidFill>
+                          <a:latin typeface="Arial"/>
+                        </a:rPr>
+                        <a:t>432</a:t>
+                      </a:r>
+                    </a:p>
+                  </a:txBody>
+                  <a:tcPr marL="45720" marR="45720" marT="13716" marB="13716" anchor="ctr">
+                    <a:solidFill>
+                      <a:srgbClr val="E9F0F6"/>
+                    </a:solidFill>
+                  </a:tcPr>
+                </a:tc>
+                <a:tc>
+                  <a:txBody>
+                    <a:bodyPr wrap="square"/>
+                    <a:lstStyle/>
+                    <a:p>
+                      <a:pPr algn="r">
+                        <a:defRPr sz="800"/>
+                      </a:pPr>
+                      <a:r>
+                        <a:rPr sz="800" b="0">
+                          <a:solidFill>
+                            <a:srgbClr val="1F2A37"/>
+                          </a:solidFill>
+                          <a:latin typeface="Arial"/>
+                        </a:rPr>
+                        <a:t>341</a:t>
+                      </a:r>
+                    </a:p>
+                  </a:txBody>
+                  <a:tcPr marL="45720" marR="45720" marT="13716" marB="13716" anchor="ctr">
+                    <a:solidFill>
+                      <a:srgbClr val="E9F0F6"/>
+                    </a:solidFill>
+                  </a:tcPr>
+                </a:tc>
+                <a:tc>
+                  <a:txBody>
+                    <a:bodyPr wrap="square"/>
+                    <a:lstStyle/>
+                    <a:p>
+                      <a:pPr algn="r">
+                        <a:defRPr sz="800"/>
+                      </a:pPr>
+                      <a:r>
+                        <a:rPr sz="800" b="0">
+                          <a:solidFill>
+                            <a:srgbClr val="1F2A37"/>
+                          </a:solidFill>
+                          <a:latin typeface="Arial"/>
+                        </a:rPr>
+                        <a:t>400</a:t>
+                      </a:r>
+                    </a:p>
+                  </a:txBody>
+                  <a:tcPr marL="45720" marR="45720" marT="13716" marB="13716" anchor="ctr">
+                    <a:solidFill>
+                      <a:srgbClr val="E9F0F6"/>
+                    </a:solidFill>
+                  </a:tcPr>
+                </a:tc>
+              </a:tr>
+              <a:tr h="173736">
+                <a:tc>
+                  <a:txBody>
+                    <a:bodyPr wrap="square"/>
+                    <a:lstStyle/>
+                    <a:p>
+                      <a:pPr algn="l">
+                        <a:defRPr sz="800"/>
+                      </a:pPr>
+                      <a:r>
+                        <a:rPr sz="800" b="0">
+                          <a:solidFill>
+                            <a:srgbClr val="1F2A37"/>
+                          </a:solidFill>
+                          <a:latin typeface="Arial"/>
+                        </a:rPr>
+                        <a:t>Global Mining</a:t>
+                      </a:r>
+                    </a:p>
+                  </a:txBody>
+                  <a:tcPr marL="45720" marR="45720" marT="13716" marB="13716" anchor="ctr">
+                    <a:solidFill>
+                      <a:srgbClr val="FFFFFF"/>
+                    </a:solidFill>
+                  </a:tcPr>
+                </a:tc>
+                <a:tc>
+                  <a:txBody>
+                    <a:bodyPr wrap="square"/>
+                    <a:lstStyle/>
+                    <a:p>
+                      <a:pPr algn="r">
+                        <a:defRPr sz="800"/>
+                      </a:pPr>
+                      <a:r>
+                        <a:rPr sz="800" b="0">
+                          <a:solidFill>
+                            <a:srgbClr val="1F2A37"/>
+                          </a:solidFill>
+                          <a:latin typeface="Arial"/>
+                        </a:rPr>
+                        <a:t>789</a:t>
+                      </a:r>
+                    </a:p>
+                  </a:txBody>
+                  <a:tcPr marL="45720" marR="45720" marT="13716" marB="13716" anchor="ctr">
+                    <a:solidFill>
+                      <a:srgbClr val="FFFFFF"/>
+                    </a:solidFill>
+                  </a:tcPr>
+                </a:tc>
+                <a:tc>
+                  <a:txBody>
+                    <a:bodyPr wrap="square"/>
+                    <a:lstStyle/>
+                    <a:p>
+                      <a:pPr algn="r">
+                        <a:defRPr sz="800"/>
+                      </a:pPr>
+                      <a:r>
+                        <a:rPr sz="800" b="0">
+                          <a:solidFill>
+                            <a:srgbClr val="1F2A37"/>
+                          </a:solidFill>
+                          <a:latin typeface="Arial"/>
+                        </a:rPr>
+                        <a:t>286</a:t>
+                      </a:r>
+                    </a:p>
+                  </a:txBody>
+                  <a:tcPr marL="45720" marR="45720" marT="13716" marB="13716" anchor="ctr">
+                    <a:solidFill>
+                      <a:srgbClr val="FFFFFF"/>
+                    </a:solidFill>
+                  </a:tcPr>
+                </a:tc>
+                <a:tc>
+                  <a:txBody>
+                    <a:bodyPr wrap="square"/>
+                    <a:lstStyle/>
+                    <a:p>
+                      <a:pPr algn="r">
+                        <a:defRPr sz="800"/>
+                      </a:pPr>
+                      <a:r>
+                        <a:rPr sz="800" b="0">
+                          <a:solidFill>
+                            <a:srgbClr val="1F2A37"/>
+                          </a:solidFill>
+                          <a:latin typeface="Arial"/>
+                        </a:rPr>
+                        <a:t>103</a:t>
+                      </a:r>
+                    </a:p>
+                  </a:txBody>
+                  <a:tcPr marL="45720" marR="45720" marT="13716" marB="13716" anchor="ctr">
+                    <a:solidFill>
+                      <a:srgbClr val="FFFFFF"/>
+                    </a:solidFill>
+                  </a:tcPr>
+                </a:tc>
+                <a:tc>
+                  <a:txBody>
+                    <a:bodyPr wrap="square"/>
+                    <a:lstStyle/>
+                    <a:p>
+                      <a:pPr algn="r">
+                        <a:defRPr sz="800"/>
+                      </a:pPr>
+                      <a:r>
+                        <a:rPr sz="800" b="0">
+                          <a:solidFill>
+                            <a:srgbClr val="1F2A37"/>
+                          </a:solidFill>
+                          <a:latin typeface="Arial"/>
+                        </a:rPr>
+                        <a:t>400</a:t>
+                      </a:r>
+                    </a:p>
+                  </a:txBody>
+                  <a:tcPr marL="45720" marR="45720" marT="13716" marB="13716" anchor="ctr">
+                    <a:solidFill>
+                      <a:srgbClr val="FFFFFF"/>
+                    </a:solidFill>
+                  </a:tcPr>
+                </a:tc>
+              </a:tr>
+              <a:tr h="173736">
+                <a:tc>
+                  <a:txBody>
+                    <a:bodyPr wrap="square"/>
+                    <a:lstStyle/>
+                    <a:p>
+                      <a:pPr algn="l">
+                        <a:defRPr sz="800"/>
+                      </a:pPr>
+                      <a:r>
+                        <a:rPr sz="800" b="0">
+                          <a:solidFill>
+                            <a:srgbClr val="1F2A37"/>
+                          </a:solidFill>
+                          <a:latin typeface="Arial"/>
+                        </a:rPr>
+                        <a:t>JESA Tech</a:t>
+                      </a:r>
+                    </a:p>
+                  </a:txBody>
+                  <a:tcPr marL="45720" marR="45720" marT="13716" marB="13716" anchor="ctr">
+                    <a:solidFill>
+                      <a:srgbClr val="E9F0F6"/>
+                    </a:solidFill>
+                  </a:tcPr>
+                </a:tc>
+                <a:tc>
+                  <a:txBody>
+                    <a:bodyPr wrap="square"/>
+                    <a:lstStyle/>
+                    <a:p>
+                      <a:pPr algn="r">
+                        <a:defRPr sz="800"/>
+                      </a:pPr>
+                      <a:r>
+                        <a:rPr sz="800" b="0">
+                          <a:solidFill>
+                            <a:srgbClr val="1F2A37"/>
+                          </a:solidFill>
+                          <a:latin typeface="Arial"/>
+                        </a:rPr>
+                        <a:t>578</a:t>
+                      </a:r>
+                    </a:p>
+                  </a:txBody>
+                  <a:tcPr marL="45720" marR="45720" marT="13716" marB="13716" anchor="ctr">
+                    <a:solidFill>
+                      <a:srgbClr val="E9F0F6"/>
+                    </a:solidFill>
+                  </a:tcPr>
+                </a:tc>
+                <a:tc>
+                  <a:txBody>
+                    <a:bodyPr wrap="square"/>
+                    <a:lstStyle/>
+                    <a:p>
+                      <a:pPr algn="r">
+                        <a:defRPr sz="800"/>
+                      </a:pPr>
+                      <a:r>
+                        <a:rPr sz="800" b="0">
+                          <a:solidFill>
+                            <a:srgbClr val="1F2A37"/>
+                          </a:solidFill>
+                          <a:latin typeface="Arial"/>
+                        </a:rPr>
+                        <a:t>337</a:t>
+                      </a:r>
+                    </a:p>
+                  </a:txBody>
+                  <a:tcPr marL="45720" marR="45720" marT="13716" marB="13716" anchor="ctr">
+                    <a:solidFill>
+                      <a:srgbClr val="E9F0F6"/>
+                    </a:solidFill>
+                  </a:tcPr>
+                </a:tc>
+                <a:tc>
+                  <a:txBody>
+                    <a:bodyPr wrap="square"/>
+                    <a:lstStyle/>
+                    <a:p>
+                      <a:pPr algn="r">
+                        <a:defRPr sz="800"/>
+                      </a:pPr>
+                      <a:r>
+                        <a:rPr sz="800" b="0">
+                          <a:solidFill>
+                            <a:srgbClr val="1F2A37"/>
+                          </a:solidFill>
+                          <a:latin typeface="Arial"/>
+                        </a:rPr>
+                        <a:t>238</a:t>
+                      </a:r>
+                    </a:p>
+                  </a:txBody>
+                  <a:tcPr marL="45720" marR="45720" marT="13716" marB="13716" anchor="ctr">
+                    <a:solidFill>
+                      <a:srgbClr val="E9F0F6"/>
+                    </a:solidFill>
+                  </a:tcPr>
+                </a:tc>
+                <a:tc>
+                  <a:txBody>
+                    <a:bodyPr wrap="square"/>
+                    <a:lstStyle/>
+                    <a:p>
+                      <a:pPr algn="r">
+                        <a:defRPr sz="800"/>
+                      </a:pPr>
+                      <a:r>
+                        <a:rPr sz="800" b="0">
+                          <a:solidFill>
+                            <a:srgbClr val="1F2A37"/>
+                          </a:solidFill>
+                          <a:latin typeface="Arial"/>
+                        </a:rPr>
+                        <a:t>3</a:t>
+                      </a:r>
+                    </a:p>
+                  </a:txBody>
+                  <a:tcPr marL="45720" marR="45720" marT="13716" marB="13716" anchor="ctr">
+                    <a:solidFill>
+                      <a:srgbClr val="E9F0F6"/>
+                    </a:solidFill>
+                  </a:tcPr>
+                </a:tc>
+              </a:tr>
+              <a:tr h="173736">
+                <a:tc>
+                  <a:txBody>
+                    <a:bodyPr wrap="square"/>
+                    <a:lstStyle/>
+                    <a:p>
+                      <a:pPr algn="l">
+                        <a:defRPr sz="800"/>
+                      </a:pPr>
+                      <a:r>
+                        <a:rPr sz="800" b="1">
+                          <a:solidFill>
+                            <a:srgbClr val="1F2A37"/>
+                          </a:solidFill>
+                          <a:latin typeface="Arial"/>
+                        </a:rPr>
+                        <a:t>Total (all BUs)</a:t>
+                      </a:r>
+                    </a:p>
+                  </a:txBody>
+                  <a:tcPr marL="45720" marR="45720" marT="13716" marB="13716" anchor="ctr">
+                    <a:solidFill>
+                      <a:srgbClr val="C9DDEE"/>
+                    </a:solidFill>
+                  </a:tcPr>
+                </a:tc>
+                <a:tc>
+                  <a:txBody>
+                    <a:bodyPr wrap="square"/>
+                    <a:lstStyle/>
+                    <a:p>
+                      <a:pPr algn="r">
+                        <a:defRPr sz="800"/>
+                      </a:pPr>
+                      <a:r>
+                        <a:rPr sz="800" b="1">
+                          <a:solidFill>
+                            <a:srgbClr val="1F2A37"/>
+                          </a:solidFill>
+                          <a:latin typeface="Arial"/>
+                        </a:rPr>
+                        <a:t>21,831</a:t>
+                      </a:r>
+                    </a:p>
+                  </a:txBody>
+                  <a:tcPr marL="45720" marR="45720" marT="13716" marB="13716" anchor="ctr">
+                    <a:solidFill>
+                      <a:srgbClr val="C9DDEE"/>
+                    </a:solidFill>
+                  </a:tcPr>
+                </a:tc>
+                <a:tc>
+                  <a:txBody>
+                    <a:bodyPr wrap="square"/>
+                    <a:lstStyle/>
+                    <a:p>
+                      <a:pPr algn="r">
+                        <a:defRPr sz="800"/>
+                      </a:pPr>
+                      <a:r>
+                        <a:rPr sz="800" b="1">
+                          <a:solidFill>
+                            <a:srgbClr val="1F2A37"/>
+                          </a:solidFill>
+                          <a:latin typeface="Arial"/>
+                        </a:rPr>
+                        <a:t>10,694</a:t>
+                      </a:r>
+                    </a:p>
+                  </a:txBody>
+                  <a:tcPr marL="45720" marR="45720" marT="13716" marB="13716" anchor="ctr">
+                    <a:solidFill>
+                      <a:srgbClr val="C9DDEE"/>
+                    </a:solidFill>
+                  </a:tcPr>
+                </a:tc>
+                <a:tc>
+                  <a:txBody>
+                    <a:bodyPr wrap="square"/>
+                    <a:lstStyle/>
+                    <a:p>
+                      <a:pPr algn="r">
+                        <a:defRPr sz="800"/>
+                      </a:pPr>
+                      <a:r>
+                        <a:rPr sz="800" b="1">
+                          <a:solidFill>
+                            <a:srgbClr val="1F2A37"/>
+                          </a:solidFill>
+                          <a:latin typeface="Arial"/>
+                        </a:rPr>
+                        <a:t>4,485</a:t>
+                      </a:r>
+                    </a:p>
+                  </a:txBody>
+                  <a:tcPr marL="45720" marR="45720" marT="13716" marB="13716" anchor="ctr">
+                    <a:solidFill>
+                      <a:srgbClr val="C9DDEE"/>
+                    </a:solidFill>
+                  </a:tcPr>
+                </a:tc>
+                <a:tc>
+                  <a:txBody>
+                    <a:bodyPr wrap="square"/>
+                    <a:lstStyle/>
+                    <a:p>
+                      <a:pPr algn="r">
+                        <a:defRPr sz="800"/>
+                      </a:pPr>
+                      <a:r>
+                        <a:rPr sz="800" b="1">
+                          <a:solidFill>
+                            <a:srgbClr val="1F2A37"/>
+                          </a:solidFill>
+                          <a:latin typeface="Arial"/>
+                        </a:rPr>
+                        <a:t>6,653</a:t>
+                      </a:r>
+                    </a:p>
+                  </a:txBody>
+                  <a:tcPr marL="45720" marR="45720" marT="13716" marB="13716" anchor="ctr">
+                    <a:solidFill>
+                      <a:srgbClr val="C9DDEE"/>
+                    </a:solidFill>
+                  </a:tcPr>
+                </a:tc>
+              </a:tr>
+            </a:tbl>
+          </a:graphicData>
+        </a:graphic>
+      </p:graphicFrame>
     </p:spTree>
   </p:cSld>
   <p:clrMapOvr>

</xml_diff>